<commit_message>
Restyle slide 5 to match reference tone and manner
Co-Authored-By: Claude Opus 5.5 <noreply@anthropic.com>
Claude-Session: https://claude.ai/code/session_014TbtPTXZRwab3hp8YY9eJi
</commit_message>
<xml_diff>
--- a/05_운영전환및발굴역량내재화.pptx
+++ b/05_운영전환및발굴역량내재화.pptx
@@ -883,8 +883,8 @@
         </p:nvSpPr>
         <p:spPr>
           <a:xfrm>
-            <a:off x="274320" y="201168"/>
-            <a:ext cx="11430000" cy="594360"/>
+            <a:off x="320040" y="182880"/>
+            <a:ext cx="11521440" cy="548640"/>
           </a:xfrm>
           <a:prstGeom prst="rect">
             <a:avLst/>
@@ -900,7 +900,7 @@
               <a:buNone/>
             </a:pPr>
             <a:r>
-              <a:rPr lang="en-US" sz="3000" b="1" dirty="0">
+              <a:rPr lang="en-US" sz="2800" b="1" dirty="0">
                 <a:solidFill>
                   <a:srgbClr val="262626"/>
                 </a:solidFill>
@@ -910,7 +910,7 @@
               </a:rPr>
               <a:t>5. Agent 운영 전환 및 발굴 역량 내재화 (案)</a:t>
             </a:r>
-            <a:endParaRPr lang="en-US" sz="3000" dirty="0"/>
+            <a:endParaRPr lang="en-US" sz="2800" dirty="0"/>
           </a:p>
         </p:txBody>
       </p:sp>
@@ -922,8 +922,8 @@
         </p:nvSpPr>
         <p:spPr>
           <a:xfrm>
-            <a:off x="365760" y="914400"/>
-            <a:ext cx="11750040" cy="594360"/>
+            <a:off x="320040" y="841248"/>
+            <a:ext cx="11521440" cy="365760"/>
           </a:xfrm>
           <a:prstGeom prst="rect">
             <a:avLst/>
@@ -941,13 +941,41 @@
             <a:r>
               <a:rPr lang="en-US" sz="1600" b="1" dirty="0">
                 <a:solidFill>
-                  <a:srgbClr val="404040"/>
-                </a:solidFill>
-                <a:latin typeface="맑은 고딕" pitchFamily="34" charset="0"/>
-                <a:ea typeface="맑은 고딕" pitchFamily="34" charset="-122"/>
-                <a:cs typeface="맑은 고딕" pitchFamily="34" charset="-120"/>
-              </a:rPr>
-              <a:t>AI혁신센터는 IS팀의 안정적인 운영 전환을 지원하고, AX컨설팅팀은 현업이 스스로 Agent Use case를 발굴할 수 있도록 교육·워크샵을 수행함</a:t>
+                  <a:srgbClr val="000000"/>
+                </a:solidFill>
+                <a:latin typeface="맑은 고딕" pitchFamily="34" charset="0"/>
+                <a:ea typeface="맑은 고딕" pitchFamily="34" charset="-122"/>
+                <a:cs typeface="맑은 고딕" pitchFamily="34" charset="-120"/>
+              </a:rPr>
+              <a:t>Agent의 지속 가능한 운영과 확산을 위해, </a:t>
+            </a:r>
+            <a:pPr indent="0" marL="0">
+              <a:buNone/>
+            </a:pPr>
+            <a:r>
+              <a:rPr lang="en-US" sz="1600" b="1" u="sng" dirty="0">
+                <a:solidFill>
+                  <a:srgbClr val="000000"/>
+                </a:solidFill>
+                <a:latin typeface="맑은 고딕" pitchFamily="34" charset="0"/>
+                <a:ea typeface="맑은 고딕" pitchFamily="34" charset="-122"/>
+                <a:cs typeface="맑은 고딕" pitchFamily="34" charset="-120"/>
+              </a:rPr>
+              <a:t>IS팀 운영 전환 지원과 현업 Use case 발굴 역량 내재화</a:t>
+            </a:r>
+            <a:pPr indent="0" marL="0">
+              <a:buNone/>
+            </a:pPr>
+            <a:r>
+              <a:rPr lang="en-US" sz="1600" b="1" dirty="0">
+                <a:solidFill>
+                  <a:srgbClr val="000000"/>
+                </a:solidFill>
+                <a:latin typeface="맑은 고딕" pitchFamily="34" charset="0"/>
+                <a:ea typeface="맑은 고딕" pitchFamily="34" charset="-122"/>
+                <a:cs typeface="맑은 고딕" pitchFamily="34" charset="-120"/>
+              </a:rPr>
+              <a:t>를 추진하고자 함</a:t>
             </a:r>
             <a:endParaRPr lang="en-US" sz="1600" dirty="0"/>
           </a:p>
@@ -961,20 +989,18 @@
         </p:nvSpPr>
         <p:spPr>
           <a:xfrm>
-            <a:off x="365760" y="1783080"/>
-            <a:ext cx="5486400" cy="457200"/>
-          </a:xfrm>
-          <a:prstGeom prst="round2SameRect">
-            <a:avLst>
-              <a:gd name="adj" fmla="val 50000"/>
-            </a:avLst>
-          </a:prstGeom>
-          <a:solidFill>
-            <a:srgbClr val="243F60"/>
+            <a:off x="320040" y="1737360"/>
+            <a:ext cx="5669280" cy="4892040"/>
+          </a:xfrm>
+          <a:prstGeom prst="rect">
+            <a:avLst/>
+          </a:prstGeom>
+          <a:solidFill>
+            <a:srgbClr val="FFFFFF"/>
           </a:solidFill>
           <a:ln w="12700">
             <a:solidFill>
-              <a:srgbClr val="243F60"/>
+              <a:srgbClr val="A6A6A6"/>
             </a:solidFill>
             <a:prstDash val="solid"/>
           </a:ln>
@@ -982,63 +1008,26 @@
       </p:sp>
       <p:sp>
         <p:nvSpPr>
-          <p:cNvPr id="5" name="Text 3"/>
-          <p:cNvSpPr txBox="1"/>
-          <p:nvPr/>
-        </p:nvSpPr>
-        <p:spPr>
-          <a:xfrm>
-            <a:off x="365760" y="1783080"/>
-            <a:ext cx="5486400" cy="457200"/>
-          </a:xfrm>
-          <a:prstGeom prst="rect">
-            <a:avLst/>
-          </a:prstGeom>
-          <a:noFill/>
-          <a:ln/>
-        </p:spPr>
-        <p:txBody>
-          <a:bodyPr wrap="square" lIns="0" tIns="0" rIns="0" bIns="0" rtlCol="0" anchor="ctr"/>
-          <a:lstStyle/>
-          <a:p>
-            <a:pPr algn="ctr" indent="0" marL="0">
-              <a:buNone/>
-            </a:pPr>
-            <a:r>
-              <a:rPr lang="en-US" sz="1400" b="1" dirty="0">
-                <a:solidFill>
-                  <a:srgbClr val="FFFFFF"/>
-                </a:solidFill>
-                <a:latin typeface="맑은 고딕" pitchFamily="34" charset="0"/>
-                <a:ea typeface="맑은 고딕" pitchFamily="34" charset="-122"/>
-                <a:cs typeface="맑은 고딕" pitchFamily="34" charset="-120"/>
-              </a:rPr>
-              <a:t>① AI혁신센터 → IS팀 운영 전환 지원</a:t>
-            </a:r>
-            <a:endParaRPr lang="en-US" sz="1400" dirty="0"/>
-          </a:p>
-        </p:txBody>
-      </p:sp>
-      <p:sp>
-        <p:nvSpPr>
-          <p:cNvPr id="6" name="Shape 4"/>
+          <p:cNvPr id="5" name="Shape 3"/>
           <p:cNvSpPr/>
           <p:nvPr/>
         </p:nvSpPr>
         <p:spPr>
           <a:xfrm>
-            <a:off x="365760" y="2240280"/>
-            <a:ext cx="5486400" cy="1691640"/>
-          </a:xfrm>
-          <a:prstGeom prst="rect">
-            <a:avLst/>
-          </a:prstGeom>
-          <a:solidFill>
-            <a:srgbClr val="F5F7FA"/>
+            <a:off x="548640" y="1307592"/>
+            <a:ext cx="5212080" cy="429768"/>
+          </a:xfrm>
+          <a:prstGeom prst="round2SameRect">
+            <a:avLst>
+              <a:gd name="adj" fmla="val 17021"/>
+            </a:avLst>
+          </a:prstGeom>
+          <a:solidFill>
+            <a:srgbClr val="404040"/>
           </a:solidFill>
           <a:ln w="12700">
             <a:solidFill>
-              <a:srgbClr val="F5F7FA"/>
+              <a:srgbClr val="404040"/>
             </a:solidFill>
             <a:prstDash val="solid"/>
           </a:ln>
@@ -1046,63 +1035,78 @@
       </p:sp>
       <p:sp>
         <p:nvSpPr>
+          <p:cNvPr id="6" name="Text 4"/>
+          <p:cNvSpPr txBox="1"/>
+          <p:nvPr/>
+        </p:nvSpPr>
+        <p:spPr>
+          <a:xfrm>
+            <a:off x="548640" y="1307592"/>
+            <a:ext cx="5212080" cy="429768"/>
+          </a:xfrm>
+          <a:prstGeom prst="rect">
+            <a:avLst/>
+          </a:prstGeom>
+          <a:noFill/>
+          <a:ln/>
+        </p:spPr>
+        <p:txBody>
+          <a:bodyPr wrap="square" lIns="0" tIns="0" rIns="0" bIns="0" rtlCol="0" anchor="ctr"/>
+          <a:lstStyle/>
+          <a:p>
+            <a:pPr algn="ctr" indent="0" marL="0">
+              <a:buNone/>
+            </a:pPr>
+            <a:r>
+              <a:rPr lang="en-US" sz="1700" b="1" dirty="0">
+                <a:solidFill>
+                  <a:srgbClr val="FFFFFF"/>
+                </a:solidFill>
+                <a:latin typeface="맑은 고딕" pitchFamily="34" charset="0"/>
+                <a:ea typeface="맑은 고딕" pitchFamily="34" charset="-122"/>
+                <a:cs typeface="맑은 고딕" pitchFamily="34" charset="-120"/>
+              </a:rPr>
+              <a:t>① IS팀 운영 전환 지원</a:t>
+            </a:r>
+            <a:endParaRPr lang="en-US" sz="1700" dirty="0"/>
+          </a:p>
+        </p:txBody>
+      </p:sp>
+      <p:sp>
+        <p:nvSpPr>
           <p:cNvPr id="7" name="Shape 5"/>
           <p:cNvSpPr/>
           <p:nvPr/>
         </p:nvSpPr>
         <p:spPr>
           <a:xfrm>
-            <a:off x="594360" y="2377440"/>
-            <a:ext cx="868680" cy="868680"/>
-          </a:xfrm>
-          <a:prstGeom prst="ellipse">
-            <a:avLst/>
-          </a:prstGeom>
-          <a:solidFill>
-            <a:srgbClr val="243F60"/>
+            <a:off x="548640" y="1874520"/>
+            <a:ext cx="1645920" cy="502920"/>
+          </a:xfrm>
+          <a:prstGeom prst="rect">
+            <a:avLst/>
+          </a:prstGeom>
+          <a:solidFill>
+            <a:srgbClr val="D9D9D9"/>
           </a:solidFill>
           <a:ln w="12700">
             <a:solidFill>
-              <a:srgbClr val="243F60"/>
+              <a:srgbClr val="D9D9D9"/>
             </a:solidFill>
             <a:prstDash val="solid"/>
           </a:ln>
         </p:spPr>
       </p:sp>
-      <p:pic>
-        <p:nvPicPr>
-          <p:cNvPr id="8" name="Image 0" descr="preencoded.png">    </p:cNvPr>
-          <p:cNvPicPr>
-            <a:picLocks noChangeAspect="1"/>
-          </p:cNvPicPr>
-          <p:nvPr/>
-        </p:nvPicPr>
-        <p:blipFill>
-          <a:blip r:embed="rId1"/>
-          <a:stretch>
-            <a:fillRect/>
-          </a:stretch>
-        </p:blipFill>
-        <p:spPr>
-          <a:xfrm>
-            <a:off x="813816" y="2596896"/>
-            <a:ext cx="429768" cy="429768"/>
-          </a:xfrm>
-          <a:prstGeom prst="rect">
-            <a:avLst/>
-          </a:prstGeom>
-        </p:spPr>
-      </p:pic>
-      <p:sp>
-        <p:nvSpPr>
-          <p:cNvPr id="9" name="Text 6"/>
+      <p:sp>
+        <p:nvSpPr>
+          <p:cNvPr id="8" name="Text 6"/>
           <p:cNvSpPr txBox="1"/>
           <p:nvPr/>
         </p:nvSpPr>
         <p:spPr>
           <a:xfrm>
-            <a:off x="320040" y="3291840"/>
-            <a:ext cx="1417320" cy="274320"/>
+            <a:off x="548640" y="1874520"/>
+            <a:ext cx="1645920" cy="502920"/>
           </a:xfrm>
           <a:prstGeom prst="rect">
             <a:avLst/>
@@ -1118,7 +1122,7 @@
               <a:buNone/>
             </a:pPr>
             <a:r>
-              <a:rPr lang="en-US" sz="1200" b="1" dirty="0">
+              <a:rPr lang="en-US" sz="1300" b="1" dirty="0">
                 <a:solidFill>
                   <a:srgbClr val="262626"/>
                 </a:solidFill>
@@ -1126,71 +1130,47 @@
                 <a:ea typeface="맑은 고딕" pitchFamily="34" charset="-122"/>
                 <a:cs typeface="맑은 고딕" pitchFamily="34" charset="-120"/>
               </a:rPr>
-              <a:t>AI혁신센터</a:t>
-            </a:r>
-            <a:endParaRPr lang="en-US" sz="1200" dirty="0"/>
-          </a:p>
-        </p:txBody>
-      </p:sp>
-      <p:sp>
-        <p:nvSpPr>
-          <p:cNvPr id="10" name="Shape 7"/>
+              <a:t>운영 자산 이관</a:t>
+            </a:r>
+            <a:endParaRPr lang="en-US" sz="1300" dirty="0"/>
+          </a:p>
+        </p:txBody>
+      </p:sp>
+      <p:sp>
+        <p:nvSpPr>
+          <p:cNvPr id="9" name="Shape 7"/>
           <p:cNvSpPr/>
           <p:nvPr/>
         </p:nvSpPr>
         <p:spPr>
           <a:xfrm>
-            <a:off x="4754880" y="2377440"/>
-            <a:ext cx="868680" cy="868680"/>
-          </a:xfrm>
-          <a:prstGeom prst="ellipse">
-            <a:avLst/>
-          </a:prstGeom>
-          <a:solidFill>
-            <a:srgbClr val="4A7BC8"/>
+            <a:off x="548640" y="2377440"/>
+            <a:ext cx="1645920" cy="594360"/>
+          </a:xfrm>
+          <a:prstGeom prst="rect">
+            <a:avLst/>
+          </a:prstGeom>
+          <a:solidFill>
+            <a:srgbClr val="FFFFFF"/>
           </a:solidFill>
           <a:ln w="12700">
             <a:solidFill>
-              <a:srgbClr val="4A7BC8"/>
+              <a:srgbClr val="D9D9D9"/>
             </a:solidFill>
             <a:prstDash val="solid"/>
           </a:ln>
         </p:spPr>
       </p:sp>
-      <p:pic>
-        <p:nvPicPr>
-          <p:cNvPr id="11" name="Image 1" descr="preencoded.png">    </p:cNvPr>
-          <p:cNvPicPr>
-            <a:picLocks noChangeAspect="1"/>
-          </p:cNvPicPr>
-          <p:nvPr/>
-        </p:nvPicPr>
-        <p:blipFill>
-          <a:blip r:embed="rId2"/>
-          <a:stretch>
-            <a:fillRect/>
-          </a:stretch>
-        </p:blipFill>
-        <p:spPr>
-          <a:xfrm>
-            <a:off x="4974336" y="2596896"/>
-            <a:ext cx="429768" cy="429768"/>
-          </a:xfrm>
-          <a:prstGeom prst="rect">
-            <a:avLst/>
-          </a:prstGeom>
-        </p:spPr>
-      </p:pic>
-      <p:sp>
-        <p:nvSpPr>
-          <p:cNvPr id="12" name="Text 8"/>
+      <p:sp>
+        <p:nvSpPr>
+          <p:cNvPr id="10" name="Text 8"/>
           <p:cNvSpPr txBox="1"/>
           <p:nvPr/>
         </p:nvSpPr>
         <p:spPr>
           <a:xfrm>
-            <a:off x="4480560" y="3291840"/>
-            <a:ext cx="1417320" cy="274320"/>
+            <a:off x="548640" y="2377440"/>
+            <a:ext cx="1645920" cy="594360"/>
           </a:xfrm>
           <a:prstGeom prst="rect">
             <a:avLst/>
@@ -1206,40 +1186,57 @@
               <a:buNone/>
             </a:pPr>
             <a:r>
-              <a:rPr lang="en-US" sz="1200" b="1" dirty="0">
-                <a:solidFill>
-                  <a:srgbClr val="262626"/>
-                </a:solidFill>
-                <a:latin typeface="맑은 고딕" pitchFamily="34" charset="0"/>
-                <a:ea typeface="맑은 고딕" pitchFamily="34" charset="-122"/>
-                <a:cs typeface="맑은 고딕" pitchFamily="34" charset="-120"/>
-              </a:rPr>
-              <a:t>IS팀</a:t>
-            </a:r>
-            <a:endParaRPr lang="en-US" sz="1200" dirty="0"/>
-          </a:p>
-        </p:txBody>
-      </p:sp>
-      <p:sp>
-        <p:nvSpPr>
-          <p:cNvPr id="13" name="Shape 9"/>
+              <a:rPr lang="en-US" sz="1050" dirty="0">
+                <a:solidFill>
+                  <a:srgbClr val="595959"/>
+                </a:solidFill>
+                <a:latin typeface="맑은 고딕" pitchFamily="34" charset="0"/>
+                <a:ea typeface="맑은 고딕" pitchFamily="34" charset="-122"/>
+                <a:cs typeface="맑은 고딕" pitchFamily="34" charset="-120"/>
+              </a:rPr>
+              <a:t>아키텍처·소스·프롬프트</a:t>
+            </a:r>
+            <a:endParaRPr lang="en-US" sz="1050" dirty="0"/>
+          </a:p>
+          <a:p>
+            <a:pPr algn="ctr" indent="0" marL="0">
+              <a:buNone/>
+            </a:pPr>
+            <a:r>
+              <a:rPr lang="en-US" sz="1050" dirty="0">
+                <a:solidFill>
+                  <a:srgbClr val="595959"/>
+                </a:solidFill>
+                <a:latin typeface="맑은 고딕" pitchFamily="34" charset="0"/>
+                <a:ea typeface="맑은 고딕" pitchFamily="34" charset="-122"/>
+                <a:cs typeface="맑은 고딕" pitchFamily="34" charset="-120"/>
+              </a:rPr>
+              <a:t>Runbook 인계</a:t>
+            </a:r>
+            <a:endParaRPr lang="en-US" sz="1050" dirty="0"/>
+          </a:p>
+        </p:txBody>
+      </p:sp>
+      <p:sp>
+        <p:nvSpPr>
+          <p:cNvPr id="11" name="Shape 9"/>
           <p:cNvSpPr/>
           <p:nvPr/>
         </p:nvSpPr>
         <p:spPr>
           <a:xfrm>
-            <a:off x="1600200" y="2587752"/>
-            <a:ext cx="987552" cy="457200"/>
-          </a:xfrm>
-          <a:prstGeom prst="homePlate">
-            <a:avLst/>
-          </a:prstGeom>
-          <a:solidFill>
-            <a:srgbClr val="8FAADC"/>
+            <a:off x="2331720" y="1874520"/>
+            <a:ext cx="1645920" cy="502920"/>
+          </a:xfrm>
+          <a:prstGeom prst="rect">
+            <a:avLst/>
+          </a:prstGeom>
+          <a:solidFill>
+            <a:srgbClr val="D9D9D9"/>
           </a:solidFill>
           <a:ln w="12700">
             <a:solidFill>
-              <a:srgbClr val="8FAADC"/>
+              <a:srgbClr val="D9D9D9"/>
             </a:solidFill>
             <a:prstDash val="solid"/>
           </a:ln>
@@ -1247,14 +1244,14 @@
       </p:sp>
       <p:sp>
         <p:nvSpPr>
-          <p:cNvPr id="14" name="Text 10"/>
+          <p:cNvPr id="12" name="Text 10"/>
           <p:cNvSpPr txBox="1"/>
           <p:nvPr/>
         </p:nvSpPr>
         <p:spPr>
           <a:xfrm>
-            <a:off x="1691640" y="2587752"/>
-            <a:ext cx="804672" cy="457200"/>
+            <a:off x="2331720" y="1874520"/>
+            <a:ext cx="1645920" cy="502920"/>
           </a:xfrm>
           <a:prstGeom prst="rect">
             <a:avLst/>
@@ -1270,40 +1267,40 @@
               <a:buNone/>
             </a:pPr>
             <a:r>
-              <a:rPr lang="en-US" sz="1150" b="1" dirty="0">
-                <a:solidFill>
-                  <a:srgbClr val="FFFFFF"/>
-                </a:solidFill>
-                <a:latin typeface="맑은 고딕" pitchFamily="34" charset="0"/>
-                <a:ea typeface="맑은 고딕" pitchFamily="34" charset="-122"/>
-                <a:cs typeface="맑은 고딕" pitchFamily="34" charset="-120"/>
-              </a:rPr>
-              <a:t>공동 운영</a:t>
-            </a:r>
-            <a:endParaRPr lang="en-US" sz="1150" dirty="0"/>
-          </a:p>
-        </p:txBody>
-      </p:sp>
-      <p:sp>
-        <p:nvSpPr>
-          <p:cNvPr id="15" name="Shape 11"/>
+              <a:rPr lang="en-US" sz="1300" b="1" dirty="0">
+                <a:solidFill>
+                  <a:srgbClr val="262626"/>
+                </a:solidFill>
+                <a:latin typeface="맑은 고딕" pitchFamily="34" charset="0"/>
+                <a:ea typeface="맑은 고딕" pitchFamily="34" charset="-122"/>
+                <a:cs typeface="맑은 고딕" pitchFamily="34" charset="-120"/>
+              </a:rPr>
+              <a:t>모니터링·품질 관리</a:t>
+            </a:r>
+            <a:endParaRPr lang="en-US" sz="1300" dirty="0"/>
+          </a:p>
+        </p:txBody>
+      </p:sp>
+      <p:sp>
+        <p:nvSpPr>
+          <p:cNvPr id="13" name="Shape 11"/>
           <p:cNvSpPr/>
           <p:nvPr/>
         </p:nvSpPr>
         <p:spPr>
           <a:xfrm>
-            <a:off x="2615184" y="2587752"/>
-            <a:ext cx="987552" cy="457200"/>
-          </a:xfrm>
-          <a:prstGeom prst="chevron">
-            <a:avLst/>
-          </a:prstGeom>
-          <a:solidFill>
-            <a:srgbClr val="4A7BC8"/>
+            <a:off x="2331720" y="2377440"/>
+            <a:ext cx="1645920" cy="594360"/>
+          </a:xfrm>
+          <a:prstGeom prst="rect">
+            <a:avLst/>
+          </a:prstGeom>
+          <a:solidFill>
+            <a:srgbClr val="FFFFFF"/>
           </a:solidFill>
           <a:ln w="12700">
             <a:solidFill>
-              <a:srgbClr val="4A7BC8"/>
+              <a:srgbClr val="D9D9D9"/>
             </a:solidFill>
             <a:prstDash val="solid"/>
           </a:ln>
@@ -1311,14 +1308,14 @@
       </p:sp>
       <p:sp>
         <p:nvSpPr>
-          <p:cNvPr id="16" name="Text 12"/>
+          <p:cNvPr id="14" name="Text 12"/>
           <p:cNvSpPr txBox="1"/>
           <p:nvPr/>
         </p:nvSpPr>
         <p:spPr>
           <a:xfrm>
-            <a:off x="2706624" y="2587752"/>
-            <a:ext cx="804672" cy="457200"/>
+            <a:off x="2331720" y="2377440"/>
+            <a:ext cx="1645920" cy="594360"/>
           </a:xfrm>
           <a:prstGeom prst="rect">
             <a:avLst/>
@@ -1334,40 +1331,57 @@
               <a:buNone/>
             </a:pPr>
             <a:r>
-              <a:rPr lang="en-US" sz="1150" b="1" dirty="0">
-                <a:solidFill>
-                  <a:srgbClr val="FFFFFF"/>
-                </a:solidFill>
-                <a:latin typeface="맑은 고딕" pitchFamily="34" charset="0"/>
-                <a:ea typeface="맑은 고딕" pitchFamily="34" charset="-122"/>
-                <a:cs typeface="맑은 고딕" pitchFamily="34" charset="-120"/>
-              </a:rPr>
-              <a:t>전환 운영</a:t>
-            </a:r>
-            <a:endParaRPr lang="en-US" sz="1150" dirty="0"/>
-          </a:p>
-        </p:txBody>
-      </p:sp>
-      <p:sp>
-        <p:nvSpPr>
-          <p:cNvPr id="17" name="Shape 13"/>
+              <a:rPr lang="en-US" sz="1050" dirty="0">
+                <a:solidFill>
+                  <a:srgbClr val="595959"/>
+                </a:solidFill>
+                <a:latin typeface="맑은 고딕" pitchFamily="34" charset="0"/>
+                <a:ea typeface="맑은 고딕" pitchFamily="34" charset="-122"/>
+                <a:cs typeface="맑은 고딕" pitchFamily="34" charset="-120"/>
+              </a:rPr>
+              <a:t>성능·비용·품질 지표</a:t>
+            </a:r>
+            <a:endParaRPr lang="en-US" sz="1050" dirty="0"/>
+          </a:p>
+          <a:p>
+            <a:pPr algn="ctr" indent="0" marL="0">
+              <a:buNone/>
+            </a:pPr>
+            <a:r>
+              <a:rPr lang="en-US" sz="1050" dirty="0">
+                <a:solidFill>
+                  <a:srgbClr val="595959"/>
+                </a:solidFill>
+                <a:latin typeface="맑은 고딕" pitchFamily="34" charset="0"/>
+                <a:ea typeface="맑은 고딕" pitchFamily="34" charset="-122"/>
+                <a:cs typeface="맑은 고딕" pitchFamily="34" charset="-120"/>
+              </a:rPr>
+              <a:t>장애 대응 절차 수립</a:t>
+            </a:r>
+            <a:endParaRPr lang="en-US" sz="1050" dirty="0"/>
+          </a:p>
+        </p:txBody>
+      </p:sp>
+      <p:sp>
+        <p:nvSpPr>
+          <p:cNvPr id="15" name="Shape 13"/>
           <p:cNvSpPr/>
           <p:nvPr/>
         </p:nvSpPr>
         <p:spPr>
           <a:xfrm>
-            <a:off x="3630168" y="2587752"/>
-            <a:ext cx="987552" cy="457200"/>
-          </a:xfrm>
-          <a:prstGeom prst="chevron">
-            <a:avLst/>
-          </a:prstGeom>
-          <a:solidFill>
-            <a:srgbClr val="243F60"/>
+            <a:off x="4114800" y="1874520"/>
+            <a:ext cx="1645920" cy="502920"/>
+          </a:xfrm>
+          <a:prstGeom prst="rect">
+            <a:avLst/>
+          </a:prstGeom>
+          <a:solidFill>
+            <a:srgbClr val="D9D9D9"/>
           </a:solidFill>
           <a:ln w="12700">
             <a:solidFill>
-              <a:srgbClr val="243F60"/>
+              <a:srgbClr val="D9D9D9"/>
             </a:solidFill>
             <a:prstDash val="solid"/>
           </a:ln>
@@ -1375,14 +1389,14 @@
       </p:sp>
       <p:sp>
         <p:nvSpPr>
-          <p:cNvPr id="18" name="Text 14"/>
+          <p:cNvPr id="16" name="Text 14"/>
           <p:cNvSpPr txBox="1"/>
           <p:nvPr/>
         </p:nvSpPr>
         <p:spPr>
           <a:xfrm>
-            <a:off x="3721608" y="2587752"/>
-            <a:ext cx="804672" cy="457200"/>
+            <a:off x="4114800" y="1874520"/>
+            <a:ext cx="1645920" cy="502920"/>
           </a:xfrm>
           <a:prstGeom prst="rect">
             <a:avLst/>
@@ -1398,79 +1412,40 @@
               <a:buNone/>
             </a:pPr>
             <a:r>
-              <a:rPr lang="en-US" sz="1150" b="1" dirty="0">
-                <a:solidFill>
-                  <a:srgbClr val="FFFFFF"/>
-                </a:solidFill>
-                <a:latin typeface="맑은 고딕" pitchFamily="34" charset="0"/>
-                <a:ea typeface="맑은 고딕" pitchFamily="34" charset="-122"/>
-                <a:cs typeface="맑은 고딕" pitchFamily="34" charset="-120"/>
-              </a:rPr>
-              <a:t>독립 운영</a:t>
-            </a:r>
-            <a:endParaRPr lang="en-US" sz="1150" dirty="0"/>
-          </a:p>
-        </p:txBody>
-      </p:sp>
-      <p:sp>
-        <p:nvSpPr>
-          <p:cNvPr id="19" name="Text 15"/>
-          <p:cNvSpPr txBox="1"/>
-          <p:nvPr/>
-        </p:nvSpPr>
-        <p:spPr>
-          <a:xfrm>
-            <a:off x="365760" y="3611880"/>
-            <a:ext cx="5486400" cy="256032"/>
-          </a:xfrm>
-          <a:prstGeom prst="rect">
-            <a:avLst/>
-          </a:prstGeom>
-          <a:noFill/>
-          <a:ln/>
-        </p:spPr>
-        <p:txBody>
-          <a:bodyPr wrap="square" lIns="0" tIns="0" rIns="0" bIns="0" rtlCol="0" anchor="ctr"/>
-          <a:lstStyle/>
-          <a:p>
-            <a:pPr algn="ctr" indent="0" marL="0">
-              <a:buNone/>
-            </a:pPr>
-            <a:r>
-              <a:rPr lang="en-US" sz="1100" i="1" dirty="0">
-                <a:solidFill>
-                  <a:srgbClr val="595959"/>
-                </a:solidFill>
-                <a:latin typeface="맑은 고딕" pitchFamily="34" charset="0"/>
-                <a:ea typeface="맑은 고딕" pitchFamily="34" charset="-122"/>
-                <a:cs typeface="맑은 고딕" pitchFamily="34" charset="-120"/>
-              </a:rPr>
-              <a:t>운영 주도권을 단계적으로 IS팀에 이관</a:t>
-            </a:r>
-            <a:endParaRPr lang="en-US" sz="1100" dirty="0"/>
-          </a:p>
-        </p:txBody>
-      </p:sp>
-      <p:sp>
-        <p:nvSpPr>
-          <p:cNvPr id="20" name="Shape 16"/>
+              <a:rPr lang="en-US" sz="1300" b="1" dirty="0">
+                <a:solidFill>
+                  <a:srgbClr val="262626"/>
+                </a:solidFill>
+                <a:latin typeface="맑은 고딕" pitchFamily="34" charset="0"/>
+                <a:ea typeface="맑은 고딕" pitchFamily="34" charset="-122"/>
+                <a:cs typeface="맑은 고딕" pitchFamily="34" charset="-120"/>
+              </a:rPr>
+              <a:t>기술 교육·안정화</a:t>
+            </a:r>
+            <a:endParaRPr lang="en-US" sz="1300" dirty="0"/>
+          </a:p>
+        </p:txBody>
+      </p:sp>
+      <p:sp>
+        <p:nvSpPr>
+          <p:cNvPr id="17" name="Shape 15"/>
           <p:cNvSpPr/>
           <p:nvPr/>
         </p:nvSpPr>
         <p:spPr>
           <a:xfrm>
-            <a:off x="502920" y="4133088"/>
-            <a:ext cx="274320" cy="274320"/>
-          </a:xfrm>
-          <a:prstGeom prst="ellipse">
-            <a:avLst/>
-          </a:prstGeom>
-          <a:solidFill>
-            <a:srgbClr val="4A7BC8"/>
+            <a:off x="4114800" y="2377440"/>
+            <a:ext cx="1645920" cy="594360"/>
+          </a:xfrm>
+          <a:prstGeom prst="rect">
+            <a:avLst/>
+          </a:prstGeom>
+          <a:solidFill>
+            <a:srgbClr val="FFFFFF"/>
           </a:solidFill>
           <a:ln w="12700">
             <a:solidFill>
-              <a:srgbClr val="4A7BC8"/>
+              <a:srgbClr val="D9D9D9"/>
             </a:solidFill>
             <a:prstDash val="solid"/>
           </a:ln>
@@ -1478,14 +1453,14 @@
       </p:sp>
       <p:sp>
         <p:nvSpPr>
-          <p:cNvPr id="21" name="Text 17"/>
+          <p:cNvPr id="18" name="Text 16"/>
           <p:cNvSpPr txBox="1"/>
           <p:nvPr/>
         </p:nvSpPr>
         <p:spPr>
           <a:xfrm>
-            <a:off x="502920" y="4133088"/>
-            <a:ext cx="274320" cy="274320"/>
+            <a:off x="4114800" y="2377440"/>
+            <a:ext cx="1645920" cy="594360"/>
           </a:xfrm>
           <a:prstGeom prst="rect">
             <a:avLst/>
@@ -1501,63 +1476,7 @@
               <a:buNone/>
             </a:pPr>
             <a:r>
-              <a:rPr lang="en-US" sz="1100" b="1" dirty="0">
-                <a:solidFill>
-                  <a:srgbClr val="FFFFFF"/>
-                </a:solidFill>
-                <a:latin typeface="맑은 고딕" pitchFamily="34" charset="0"/>
-                <a:ea typeface="맑은 고딕" pitchFamily="34" charset="-122"/>
-                <a:cs typeface="맑은 고딕" pitchFamily="34" charset="-120"/>
-              </a:rPr>
-              <a:t>1</a:t>
-            </a:r>
-            <a:endParaRPr lang="en-US" sz="1100" dirty="0"/>
-          </a:p>
-        </p:txBody>
-      </p:sp>
-      <p:sp>
-        <p:nvSpPr>
-          <p:cNvPr id="22" name="Text 18"/>
-          <p:cNvSpPr txBox="1"/>
-          <p:nvPr/>
-        </p:nvSpPr>
-        <p:spPr>
-          <a:xfrm>
-            <a:off x="914400" y="4041648"/>
-            <a:ext cx="4846320" cy="475488"/>
-          </a:xfrm>
-          <a:prstGeom prst="rect">
-            <a:avLst/>
-          </a:prstGeom>
-          <a:noFill/>
-          <a:ln/>
-        </p:spPr>
-        <p:txBody>
-          <a:bodyPr wrap="square" lIns="0" tIns="0" rIns="0" bIns="0" rtlCol="0" anchor="ctr"/>
-          <a:lstStyle/>
-          <a:p>
-            <a:pPr indent="0" marL="0">
-              <a:buNone/>
-            </a:pPr>
-            <a:r>
-              <a:rPr lang="en-US" sz="1300" b="1" dirty="0">
-                <a:solidFill>
-                  <a:srgbClr val="262626"/>
-                </a:solidFill>
-                <a:latin typeface="맑은 고딕" pitchFamily="34" charset="0"/>
-                <a:ea typeface="맑은 고딕" pitchFamily="34" charset="-122"/>
-                <a:cs typeface="맑은 고딕" pitchFamily="34" charset="-120"/>
-              </a:rPr>
-              <a:t>운영 자산 이관</a:t>
-            </a:r>
-            <a:endParaRPr lang="en-US" sz="1300" dirty="0"/>
-          </a:p>
-          <a:p>
-            <a:pPr indent="0" marL="0">
-              <a:buNone/>
-            </a:pPr>
-            <a:r>
-              <a:rPr lang="en-US" sz="1100" dirty="0">
+              <a:rPr lang="en-US" sz="1050" dirty="0">
                 <a:solidFill>
                   <a:srgbClr val="595959"/>
                 </a:solidFill>
@@ -1565,32 +1484,49 @@
                 <a:ea typeface="맑은 고딕" pitchFamily="34" charset="-122"/>
                 <a:cs typeface="맑은 고딕" pitchFamily="34" charset="-120"/>
               </a:rPr>
-              <a:t>아키텍처·소스·프롬프트 및 운영 매뉴얼(Runbook) 인계</a:t>
-            </a:r>
-            <a:endParaRPr lang="en-US" sz="1300" dirty="0"/>
-          </a:p>
-        </p:txBody>
-      </p:sp>
-      <p:sp>
-        <p:nvSpPr>
-          <p:cNvPr id="23" name="Shape 19"/>
+              <a:t>Agent 플랫폼·LLMOps 교육</a:t>
+            </a:r>
+            <a:endParaRPr lang="en-US" sz="1050" dirty="0"/>
+          </a:p>
+          <a:p>
+            <a:pPr algn="ctr" indent="0" marL="0">
+              <a:buNone/>
+            </a:pPr>
+            <a:r>
+              <a:rPr lang="en-US" sz="1050" dirty="0">
+                <a:solidFill>
+                  <a:srgbClr val="595959"/>
+                </a:solidFill>
+                <a:latin typeface="맑은 고딕" pitchFamily="34" charset="0"/>
+                <a:ea typeface="맑은 고딕" pitchFamily="34" charset="-122"/>
+                <a:cs typeface="맑은 고딕" pitchFamily="34" charset="-120"/>
+              </a:rPr>
+              <a:t>이관 후 2선 기술 지원</a:t>
+            </a:r>
+            <a:endParaRPr lang="en-US" sz="1050" dirty="0"/>
+          </a:p>
+        </p:txBody>
+      </p:sp>
+      <p:sp>
+        <p:nvSpPr>
+          <p:cNvPr id="19" name="Shape 17"/>
           <p:cNvSpPr/>
           <p:nvPr/>
         </p:nvSpPr>
         <p:spPr>
-          <a:xfrm>
-            <a:off x="502920" y="4608576"/>
-            <a:ext cx="274320" cy="274320"/>
-          </a:xfrm>
-          <a:prstGeom prst="ellipse">
-            <a:avLst/>
-          </a:prstGeom>
-          <a:solidFill>
-            <a:srgbClr val="4A7BC8"/>
+          <a:xfrm flipV="1">
+            <a:off x="548640" y="2971800"/>
+            <a:ext cx="5212080" cy="228600"/>
+          </a:xfrm>
+          <a:prstGeom prst="trapezoid">
+            <a:avLst/>
+          </a:prstGeom>
+          <a:solidFill>
+            <a:srgbClr val="E7E6E6"/>
           </a:solidFill>
           <a:ln w="12700">
             <a:solidFill>
-              <a:srgbClr val="4A7BC8"/>
+              <a:srgbClr val="E7E6E6"/>
             </a:solidFill>
             <a:prstDash val="solid"/>
           </a:ln>
@@ -1598,14 +1534,14 @@
       </p:sp>
       <p:sp>
         <p:nvSpPr>
-          <p:cNvPr id="24" name="Text 20"/>
+          <p:cNvPr id="20" name="Text 18"/>
           <p:cNvSpPr txBox="1"/>
           <p:nvPr/>
         </p:nvSpPr>
         <p:spPr>
           <a:xfrm>
-            <a:off x="502920" y="4608576"/>
-            <a:ext cx="274320" cy="274320"/>
+            <a:off x="320040" y="3218688"/>
+            <a:ext cx="5669280" cy="594360"/>
           </a:xfrm>
           <a:prstGeom prst="rect">
             <a:avLst/>
@@ -1621,96 +1557,59 @@
               <a:buNone/>
             </a:pPr>
             <a:r>
-              <a:rPr lang="en-US" sz="1100" b="1" dirty="0">
-                <a:solidFill>
-                  <a:srgbClr val="FFFFFF"/>
-                </a:solidFill>
-                <a:latin typeface="맑은 고딕" pitchFamily="34" charset="0"/>
-                <a:ea typeface="맑은 고딕" pitchFamily="34" charset="-122"/>
-                <a:cs typeface="맑은 고딕" pitchFamily="34" charset="-120"/>
-              </a:rPr>
-              <a:t>2</a:t>
-            </a:r>
-            <a:endParaRPr lang="en-US" sz="1100" dirty="0"/>
-          </a:p>
-        </p:txBody>
-      </p:sp>
-      <p:sp>
-        <p:nvSpPr>
-          <p:cNvPr id="25" name="Text 21"/>
-          <p:cNvSpPr txBox="1"/>
-          <p:nvPr/>
-        </p:nvSpPr>
-        <p:spPr>
-          <a:xfrm>
-            <a:off x="914400" y="4517136"/>
-            <a:ext cx="4846320" cy="475488"/>
-          </a:xfrm>
-          <a:prstGeom prst="rect">
-            <a:avLst/>
-          </a:prstGeom>
-          <a:noFill/>
-          <a:ln/>
-        </p:spPr>
-        <p:txBody>
-          <a:bodyPr wrap="square" lIns="0" tIns="0" rIns="0" bIns="0" rtlCol="0" anchor="ctr"/>
-          <a:lstStyle/>
-          <a:p>
-            <a:pPr indent="0" marL="0">
-              <a:buNone/>
-            </a:pPr>
-            <a:r>
-              <a:rPr lang="en-US" sz="1300" b="1" dirty="0">
-                <a:solidFill>
-                  <a:srgbClr val="262626"/>
-                </a:solidFill>
-                <a:latin typeface="맑은 고딕" pitchFamily="34" charset="0"/>
-                <a:ea typeface="맑은 고딕" pitchFamily="34" charset="-122"/>
-                <a:cs typeface="맑은 고딕" pitchFamily="34" charset="-120"/>
-              </a:rPr>
-              <a:t>모니터링·품질 관리 체계</a:t>
-            </a:r>
-            <a:endParaRPr lang="en-US" sz="1300" dirty="0"/>
-          </a:p>
-          <a:p>
-            <a:pPr indent="0" marL="0">
-              <a:buNone/>
-            </a:pPr>
-            <a:r>
-              <a:rPr lang="en-US" sz="1100" dirty="0">
-                <a:solidFill>
-                  <a:srgbClr val="595959"/>
-                </a:solidFill>
-                <a:latin typeface="맑은 고딕" pitchFamily="34" charset="0"/>
-                <a:ea typeface="맑은 고딕" pitchFamily="34" charset="-122"/>
-                <a:cs typeface="맑은 고딕" pitchFamily="34" charset="-120"/>
-              </a:rPr>
-              <a:t>성능·비용·응답 품질 지표 및 장애 대응 절차 수립</a:t>
-            </a:r>
-            <a:endParaRPr lang="en-US" sz="1300" dirty="0"/>
-          </a:p>
-        </p:txBody>
-      </p:sp>
-      <p:sp>
-        <p:nvSpPr>
-          <p:cNvPr id="26" name="Shape 22"/>
+              <a:rPr lang="en-US" sz="1500" b="1" dirty="0">
+                <a:solidFill>
+                  <a:srgbClr val="404040"/>
+                </a:solidFill>
+                <a:latin typeface="맑은 고딕" pitchFamily="34" charset="0"/>
+                <a:ea typeface="맑은 고딕" pitchFamily="34" charset="-122"/>
+                <a:cs typeface="맑은 고딕" pitchFamily="34" charset="-120"/>
+              </a:rPr>
+              <a:t>공동 운영 → 전환 운영 → 독립 운영 단계를 거친</a:t>
+            </a:r>
+            <a:endParaRPr lang="en-US" sz="1500" dirty="0"/>
+          </a:p>
+          <a:p>
+            <a:pPr algn="ctr" indent="0" marL="0">
+              <a:buNone/>
+            </a:pPr>
+            <a:r>
+              <a:rPr lang="en-US" sz="1700" b="1" dirty="0">
+                <a:solidFill>
+                  <a:srgbClr val="1F3864"/>
+                </a:solidFill>
+                <a:latin typeface="맑은 고딕" pitchFamily="34" charset="0"/>
+                <a:ea typeface="맑은 고딕" pitchFamily="34" charset="-122"/>
+                <a:cs typeface="맑은 고딕" pitchFamily="34" charset="-120"/>
+              </a:rPr>
+              <a:t>IS팀 중심의 안정적 Agent 운영</a:t>
+            </a:r>
+            <a:endParaRPr lang="en-US" sz="1500" dirty="0"/>
+          </a:p>
+        </p:txBody>
+      </p:sp>
+      <p:sp>
+        <p:nvSpPr>
+          <p:cNvPr id="21" name="Shape 19"/>
           <p:cNvSpPr/>
           <p:nvPr/>
         </p:nvSpPr>
         <p:spPr>
           <a:xfrm>
-            <a:off x="502920" y="5084064"/>
-            <a:ext cx="274320" cy="274320"/>
-          </a:xfrm>
-          <a:prstGeom prst="ellipse">
-            <a:avLst/>
-          </a:prstGeom>
-          <a:solidFill>
-            <a:srgbClr val="4A7BC8"/>
-          </a:solidFill>
-          <a:ln w="12700">
+            <a:off x="548640" y="3931920"/>
+            <a:ext cx="5212080" cy="2560320"/>
+          </a:xfrm>
+          <a:prstGeom prst="roundRect">
+            <a:avLst>
+              <a:gd name="adj" fmla="val 3571"/>
+            </a:avLst>
+          </a:prstGeom>
+          <a:solidFill>
+            <a:srgbClr val="F2F2F2"/>
+          </a:solidFill>
+          <a:ln w="9525">
             <a:solidFill>
-              <a:srgbClr val="4A7BC8"/>
+              <a:srgbClr val="D9D9D9"/>
             </a:solidFill>
             <a:prstDash val="solid"/>
           </a:ln>
@@ -1718,119 +1617,26 @@
       </p:sp>
       <p:sp>
         <p:nvSpPr>
-          <p:cNvPr id="27" name="Text 23"/>
-          <p:cNvSpPr txBox="1"/>
-          <p:nvPr/>
-        </p:nvSpPr>
-        <p:spPr>
-          <a:xfrm>
-            <a:off x="502920" y="5084064"/>
-            <a:ext cx="274320" cy="274320"/>
-          </a:xfrm>
-          <a:prstGeom prst="rect">
-            <a:avLst/>
-          </a:prstGeom>
-          <a:noFill/>
-          <a:ln/>
-        </p:spPr>
-        <p:txBody>
-          <a:bodyPr wrap="square" lIns="0" tIns="0" rIns="0" bIns="0" rtlCol="0" anchor="ctr"/>
-          <a:lstStyle/>
-          <a:p>
-            <a:pPr algn="ctr" indent="0" marL="0">
-              <a:buNone/>
-            </a:pPr>
-            <a:r>
-              <a:rPr lang="en-US" sz="1100" b="1" dirty="0">
-                <a:solidFill>
-                  <a:srgbClr val="FFFFFF"/>
-                </a:solidFill>
-                <a:latin typeface="맑은 고딕" pitchFamily="34" charset="0"/>
-                <a:ea typeface="맑은 고딕" pitchFamily="34" charset="-122"/>
-                <a:cs typeface="맑은 고딕" pitchFamily="34" charset="-120"/>
-              </a:rPr>
-              <a:t>3</a:t>
-            </a:r>
-            <a:endParaRPr lang="en-US" sz="1100" dirty="0"/>
-          </a:p>
-        </p:txBody>
-      </p:sp>
-      <p:sp>
-        <p:nvSpPr>
-          <p:cNvPr id="28" name="Text 24"/>
-          <p:cNvSpPr txBox="1"/>
-          <p:nvPr/>
-        </p:nvSpPr>
-        <p:spPr>
-          <a:xfrm>
-            <a:off x="914400" y="4992624"/>
-            <a:ext cx="4846320" cy="475488"/>
-          </a:xfrm>
-          <a:prstGeom prst="rect">
-            <a:avLst/>
-          </a:prstGeom>
-          <a:noFill/>
-          <a:ln/>
-        </p:spPr>
-        <p:txBody>
-          <a:bodyPr wrap="square" lIns="0" tIns="0" rIns="0" bIns="0" rtlCol="0" anchor="ctr"/>
-          <a:lstStyle/>
-          <a:p>
-            <a:pPr indent="0" marL="0">
-              <a:buNone/>
-            </a:pPr>
-            <a:r>
-              <a:rPr lang="en-US" sz="1300" b="1" dirty="0">
-                <a:solidFill>
-                  <a:srgbClr val="262626"/>
-                </a:solidFill>
-                <a:latin typeface="맑은 고딕" pitchFamily="34" charset="0"/>
-                <a:ea typeface="맑은 고딕" pitchFamily="34" charset="-122"/>
-                <a:cs typeface="맑은 고딕" pitchFamily="34" charset="-120"/>
-              </a:rPr>
-              <a:t>기술 교육 및 공동 운영</a:t>
-            </a:r>
-            <a:endParaRPr lang="en-US" sz="1300" dirty="0"/>
-          </a:p>
-          <a:p>
-            <a:pPr indent="0" marL="0">
-              <a:buNone/>
-            </a:pPr>
-            <a:r>
-              <a:rPr lang="en-US" sz="1100" dirty="0">
-                <a:solidFill>
-                  <a:srgbClr val="595959"/>
-                </a:solidFill>
-                <a:latin typeface="맑은 고딕" pitchFamily="34" charset="0"/>
-                <a:ea typeface="맑은 고딕" pitchFamily="34" charset="-122"/>
-                <a:cs typeface="맑은 고딕" pitchFamily="34" charset="-120"/>
-              </a:rPr>
-              <a:t>Agent 플랫폼·LLMOps 교육, 공동 운영 기간 운영</a:t>
-            </a:r>
-            <a:endParaRPr lang="en-US" sz="1300" dirty="0"/>
-          </a:p>
-        </p:txBody>
-      </p:sp>
-      <p:sp>
-        <p:nvSpPr>
-          <p:cNvPr id="29" name="Shape 25"/>
+          <p:cNvPr id="22" name="Shape 20"/>
           <p:cNvSpPr/>
           <p:nvPr/>
         </p:nvSpPr>
         <p:spPr>
           <a:xfrm>
-            <a:off x="502920" y="5559552"/>
-            <a:ext cx="274320" cy="274320"/>
-          </a:xfrm>
-          <a:prstGeom prst="ellipse">
-            <a:avLst/>
-          </a:prstGeom>
-          <a:solidFill>
-            <a:srgbClr val="4A7BC8"/>
+            <a:off x="548640" y="3931920"/>
+            <a:ext cx="5212080" cy="411480"/>
+          </a:xfrm>
+          <a:prstGeom prst="round2SameRect">
+            <a:avLst>
+              <a:gd name="adj" fmla="val 22222"/>
+            </a:avLst>
+          </a:prstGeom>
+          <a:solidFill>
+            <a:srgbClr val="A6A6A6"/>
           </a:solidFill>
           <a:ln w="12700">
             <a:solidFill>
-              <a:srgbClr val="4A7BC8"/>
+              <a:srgbClr val="A6A6A6"/>
             </a:solidFill>
             <a:prstDash val="solid"/>
           </a:ln>
@@ -1838,14 +1644,14 @@
       </p:sp>
       <p:sp>
         <p:nvSpPr>
-          <p:cNvPr id="30" name="Text 26"/>
+          <p:cNvPr id="23" name="Text 21"/>
           <p:cNvSpPr txBox="1"/>
           <p:nvPr/>
         </p:nvSpPr>
         <p:spPr>
           <a:xfrm>
-            <a:off x="502920" y="5559552"/>
-            <a:ext cx="274320" cy="274320"/>
+            <a:off x="548640" y="3931920"/>
+            <a:ext cx="5212080" cy="411480"/>
           </a:xfrm>
           <a:prstGeom prst="rect">
             <a:avLst/>
@@ -1861,7 +1667,7 @@
               <a:buNone/>
             </a:pPr>
             <a:r>
-              <a:rPr lang="en-US" sz="1100" b="1" dirty="0">
+              <a:rPr lang="en-US" sz="1450" b="1" dirty="0">
                 <a:solidFill>
                   <a:srgbClr val="FFFFFF"/>
                 </a:solidFill>
@@ -1869,88 +1675,60 @@
                 <a:ea typeface="맑은 고딕" pitchFamily="34" charset="-122"/>
                 <a:cs typeface="맑은 고딕" pitchFamily="34" charset="-120"/>
               </a:rPr>
-              <a:t>4</a:t>
-            </a:r>
-            <a:endParaRPr lang="en-US" sz="1100" dirty="0"/>
-          </a:p>
-        </p:txBody>
-      </p:sp>
-      <p:sp>
-        <p:nvSpPr>
-          <p:cNvPr id="31" name="Text 27"/>
-          <p:cNvSpPr txBox="1"/>
-          <p:nvPr/>
-        </p:nvSpPr>
-        <p:spPr>
-          <a:xfrm>
-            <a:off x="914400" y="5468112"/>
-            <a:ext cx="4846320" cy="475488"/>
-          </a:xfrm>
-          <a:prstGeom prst="rect">
-            <a:avLst/>
-          </a:prstGeom>
-          <a:noFill/>
-          <a:ln/>
-        </p:spPr>
-        <p:txBody>
-          <a:bodyPr wrap="square" lIns="0" tIns="0" rIns="0" bIns="0" rtlCol="0" anchor="ctr"/>
-          <a:lstStyle/>
-          <a:p>
-            <a:pPr indent="0" marL="0">
-              <a:buNone/>
-            </a:pPr>
-            <a:r>
-              <a:rPr lang="en-US" sz="1300" b="1" dirty="0">
-                <a:solidFill>
-                  <a:srgbClr val="262626"/>
-                </a:solidFill>
-                <a:latin typeface="맑은 고딕" pitchFamily="34" charset="0"/>
-                <a:ea typeface="맑은 고딕" pitchFamily="34" charset="-122"/>
-                <a:cs typeface="맑은 고딕" pitchFamily="34" charset="-120"/>
-              </a:rPr>
-              <a:t>이관 후 기술 지원</a:t>
-            </a:r>
-            <a:endParaRPr lang="en-US" sz="1300" dirty="0"/>
-          </a:p>
-          <a:p>
-            <a:pPr indent="0" marL="0">
-              <a:buNone/>
-            </a:pPr>
-            <a:r>
-              <a:rPr lang="en-US" sz="1100" dirty="0">
-                <a:solidFill>
-                  <a:srgbClr val="595959"/>
-                </a:solidFill>
-                <a:latin typeface="맑은 고딕" pitchFamily="34" charset="0"/>
-                <a:ea typeface="맑은 고딕" pitchFamily="34" charset="-122"/>
-                <a:cs typeface="맑은 고딕" pitchFamily="34" charset="-120"/>
-              </a:rPr>
-              <a:t>안정화 기간 2선 지원 및 고도화 요청 대응</a:t>
-            </a:r>
-            <a:endParaRPr lang="en-US" sz="1300" dirty="0"/>
-          </a:p>
-        </p:txBody>
-      </p:sp>
-      <p:sp>
-        <p:nvSpPr>
-          <p:cNvPr id="32" name="Shape 28"/>
+              <a:t>역할 분담</a:t>
+            </a:r>
+            <a:pPr algn="ctr" indent="0" marL="0">
+              <a:buNone/>
+            </a:pPr>
+            <a:r>
+              <a:rPr lang="en-US" sz="1450" dirty="0">
+                <a:solidFill>
+                  <a:srgbClr val="FFFFFF"/>
+                </a:solidFill>
+                <a:latin typeface="맑은 고딕" pitchFamily="34" charset="0"/>
+                <a:ea typeface="맑은 고딕" pitchFamily="34" charset="-122"/>
+                <a:cs typeface="맑은 고딕" pitchFamily="34" charset="-120"/>
+              </a:rPr>
+              <a:t> 기반의 </a:t>
+            </a:r>
+            <a:pPr algn="ctr" indent="0" marL="0">
+              <a:buNone/>
+            </a:pPr>
+            <a:r>
+              <a:rPr lang="en-US" sz="1450" b="1" dirty="0">
+                <a:solidFill>
+                  <a:srgbClr val="FFFFFF"/>
+                </a:solidFill>
+                <a:latin typeface="맑은 고딕" pitchFamily="34" charset="0"/>
+                <a:ea typeface="맑은 고딕" pitchFamily="34" charset="-122"/>
+                <a:cs typeface="맑은 고딕" pitchFamily="34" charset="-120"/>
+              </a:rPr>
+              <a:t>단계적 운영 이관 체계 확보</a:t>
+            </a:r>
+            <a:endParaRPr lang="en-US" sz="1450" dirty="0"/>
+          </a:p>
+        </p:txBody>
+      </p:sp>
+      <p:sp>
+        <p:nvSpPr>
+          <p:cNvPr id="24" name="Shape 22"/>
           <p:cNvSpPr/>
           <p:nvPr/>
         </p:nvSpPr>
         <p:spPr>
           <a:xfrm>
-            <a:off x="365760" y="6080760"/>
-            <a:ext cx="5486400" cy="457200"/>
-          </a:xfrm>
-          <a:prstGeom prst="rect">
-            <a:avLst/>
-          </a:prstGeom>
-          <a:solidFill>
-            <a:srgbClr val="EAF0F8"/>
+            <a:off x="1874520" y="4526280"/>
+            <a:ext cx="2606040" cy="731520"/>
+          </a:xfrm>
+          <a:prstGeom prst="leftArrow">
+            <a:avLst/>
+          </a:prstGeom>
+          <a:solidFill>
+            <a:srgbClr val="D6DCE5"/>
           </a:solidFill>
           <a:ln w="12700">
             <a:solidFill>
-              <a:srgbClr val="EAF0F8"/>
+              <a:srgbClr val="D6DCE5"/>
             </a:solidFill>
             <a:prstDash val="solid"/>
           </a:ln>
@@ -1958,14 +1736,14 @@
       </p:sp>
       <p:sp>
         <p:nvSpPr>
-          <p:cNvPr id="33" name="Text 29"/>
+          <p:cNvPr id="25" name="Text 23"/>
           <p:cNvSpPr txBox="1"/>
           <p:nvPr/>
         </p:nvSpPr>
         <p:spPr>
           <a:xfrm>
-            <a:off x="365760" y="6080760"/>
-            <a:ext cx="5486400" cy="457200"/>
+            <a:off x="2240280" y="4526280"/>
+            <a:ext cx="1828800" cy="731520"/>
           </a:xfrm>
           <a:prstGeom prst="rect">
             <a:avLst/>
@@ -1981,56 +1759,57 @@
               <a:buNone/>
             </a:pPr>
             <a:r>
-              <a:rPr lang="en-US" sz="1300" b="1" dirty="0">
-                <a:solidFill>
-                  <a:srgbClr val="4A7BC8"/>
-                </a:solidFill>
-                <a:latin typeface="맑은 고딕" pitchFamily="34" charset="0"/>
-                <a:ea typeface="맑은 고딕" pitchFamily="34" charset="-122"/>
-                <a:cs typeface="맑은 고딕" pitchFamily="34" charset="-120"/>
-              </a:rPr>
-              <a:t>산출물  </a:t>
-            </a:r>
-            <a:pPr algn="ctr" indent="0" marL="0">
-              <a:buNone/>
-            </a:pPr>
-            <a:r>
-              <a:rPr lang="en-US" sz="1300" b="1" dirty="0">
-                <a:solidFill>
-                  <a:srgbClr val="262626"/>
-                </a:solidFill>
-                <a:latin typeface="맑은 고딕" pitchFamily="34" charset="0"/>
-                <a:ea typeface="맑은 고딕" pitchFamily="34" charset="-122"/>
-                <a:cs typeface="맑은 고딕" pitchFamily="34" charset="-120"/>
-              </a:rPr>
-              <a:t>운영 매뉴얼, 모니터링 체계, 운영 이관 확인서</a:t>
-            </a:r>
-            <a:endParaRPr lang="en-US" sz="1300" dirty="0"/>
-          </a:p>
-        </p:txBody>
-      </p:sp>
-      <p:sp>
-        <p:nvSpPr>
-          <p:cNvPr id="34" name="Shape 30"/>
+              <a:rPr lang="en-US" sz="1100" b="1" i="1" dirty="0">
+                <a:solidFill>
+                  <a:srgbClr val="404040"/>
+                </a:solidFill>
+                <a:latin typeface="맑은 고딕" pitchFamily="34" charset="0"/>
+                <a:ea typeface="맑은 고딕" pitchFamily="34" charset="-122"/>
+                <a:cs typeface="맑은 고딕" pitchFamily="34" charset="-120"/>
+              </a:rPr>
+              <a:t>운영 자산 이관</a:t>
+            </a:r>
+            <a:endParaRPr lang="en-US" sz="1100" dirty="0"/>
+          </a:p>
+          <a:p>
+            <a:pPr algn="ctr" indent="0" marL="0">
+              <a:buNone/>
+            </a:pPr>
+            <a:r>
+              <a:rPr lang="en-US" sz="1100" b="1" i="1" dirty="0">
+                <a:solidFill>
+                  <a:srgbClr val="404040"/>
+                </a:solidFill>
+                <a:latin typeface="맑은 고딕" pitchFamily="34" charset="0"/>
+                <a:ea typeface="맑은 고딕" pitchFamily="34" charset="-122"/>
+                <a:cs typeface="맑은 고딕" pitchFamily="34" charset="-120"/>
+              </a:rPr>
+              <a:t>기술 교육 · 2선 지원</a:t>
+            </a:r>
+            <a:endParaRPr lang="en-US" sz="1100" dirty="0"/>
+          </a:p>
+        </p:txBody>
+      </p:sp>
+      <p:sp>
+        <p:nvSpPr>
+          <p:cNvPr id="26" name="Shape 24"/>
           <p:cNvSpPr/>
           <p:nvPr/>
         </p:nvSpPr>
         <p:spPr>
           <a:xfrm>
-            <a:off x="6336792" y="1783080"/>
-            <a:ext cx="5486400" cy="457200"/>
-          </a:xfrm>
-          <a:prstGeom prst="round2SameRect">
-            <a:avLst>
-              <a:gd name="adj" fmla="val 50000"/>
-            </a:avLst>
-          </a:prstGeom>
-          <a:solidFill>
-            <a:srgbClr val="243F60"/>
+            <a:off x="1828800" y="5577840"/>
+            <a:ext cx="2606040" cy="731520"/>
+          </a:xfrm>
+          <a:prstGeom prst="rightArrow">
+            <a:avLst/>
+          </a:prstGeom>
+          <a:solidFill>
+            <a:srgbClr val="F6DADA"/>
           </a:solidFill>
           <a:ln w="12700">
             <a:solidFill>
-              <a:srgbClr val="243F60"/>
+              <a:srgbClr val="F6DADA"/>
             </a:solidFill>
             <a:prstDash val="solid"/>
           </a:ln>
@@ -2038,14 +1817,14 @@
       </p:sp>
       <p:sp>
         <p:nvSpPr>
-          <p:cNvPr id="35" name="Text 31"/>
+          <p:cNvPr id="27" name="Text 25"/>
           <p:cNvSpPr txBox="1"/>
           <p:nvPr/>
         </p:nvSpPr>
         <p:spPr>
           <a:xfrm>
-            <a:off x="6336792" y="1783080"/>
-            <a:ext cx="5486400" cy="457200"/>
+            <a:off x="2148840" y="5577840"/>
+            <a:ext cx="1828800" cy="731520"/>
           </a:xfrm>
           <a:prstGeom prst="rect">
             <a:avLst/>
@@ -2061,40 +1840,96 @@
               <a:buNone/>
             </a:pPr>
             <a:r>
-              <a:rPr lang="en-US" sz="1400" b="1" dirty="0">
-                <a:solidFill>
-                  <a:srgbClr val="FFFFFF"/>
-                </a:solidFill>
-                <a:latin typeface="맑은 고딕" pitchFamily="34" charset="0"/>
-                <a:ea typeface="맑은 고딕" pitchFamily="34" charset="-122"/>
-                <a:cs typeface="맑은 고딕" pitchFamily="34" charset="-120"/>
-              </a:rPr>
-              <a:t>② AX컨설팅팀 → 현업 Use case 발굴 교육·워크샵</a:t>
-            </a:r>
-            <a:endParaRPr lang="en-US" sz="1400" dirty="0"/>
-          </a:p>
-        </p:txBody>
-      </p:sp>
-      <p:sp>
-        <p:nvSpPr>
-          <p:cNvPr id="36" name="Shape 32"/>
+              <a:rPr lang="en-US" sz="1100" b="1" i="1" dirty="0">
+                <a:solidFill>
+                  <a:srgbClr val="404040"/>
+                </a:solidFill>
+                <a:latin typeface="맑은 고딕" pitchFamily="34" charset="0"/>
+                <a:ea typeface="맑은 고딕" pitchFamily="34" charset="-122"/>
+                <a:cs typeface="맑은 고딕" pitchFamily="34" charset="-120"/>
+              </a:rPr>
+              <a:t>운영 이슈 공유</a:t>
+            </a:r>
+            <a:endParaRPr lang="en-US" sz="1100" dirty="0"/>
+          </a:p>
+          <a:p>
+            <a:pPr algn="ctr" indent="0" marL="0">
+              <a:buNone/>
+            </a:pPr>
+            <a:r>
+              <a:rPr lang="en-US" sz="1100" b="1" i="1" dirty="0">
+                <a:solidFill>
+                  <a:srgbClr val="404040"/>
+                </a:solidFill>
+                <a:latin typeface="맑은 고딕" pitchFamily="34" charset="0"/>
+                <a:ea typeface="맑은 고딕" pitchFamily="34" charset="-122"/>
+                <a:cs typeface="맑은 고딕" pitchFamily="34" charset="-120"/>
+              </a:rPr>
+              <a:t>고도화 요청</a:t>
+            </a:r>
+            <a:endParaRPr lang="en-US" sz="1100" dirty="0"/>
+          </a:p>
+        </p:txBody>
+      </p:sp>
+      <p:sp>
+        <p:nvSpPr>
+          <p:cNvPr id="28" name="Text 26"/>
+          <p:cNvSpPr txBox="1"/>
+          <p:nvPr/>
+        </p:nvSpPr>
+        <p:spPr>
+          <a:xfrm>
+            <a:off x="2011680" y="5303520"/>
+            <a:ext cx="2103120" cy="274320"/>
+          </a:xfrm>
+          <a:prstGeom prst="rect">
+            <a:avLst/>
+          </a:prstGeom>
+          <a:noFill/>
+          <a:ln/>
+        </p:spPr>
+        <p:txBody>
+          <a:bodyPr wrap="square" lIns="0" tIns="0" rIns="0" bIns="0" rtlCol="0" anchor="ctr"/>
+          <a:lstStyle/>
+          <a:p>
+            <a:pPr algn="ctr" indent="0" marL="0">
+              <a:buNone/>
+            </a:pPr>
+            <a:r>
+              <a:rPr lang="en-US" sz="1300" b="1" dirty="0">
+                <a:solidFill>
+                  <a:srgbClr val="BFBFBF"/>
+                </a:solidFill>
+                <a:latin typeface="맑은 고딕" pitchFamily="34" charset="0"/>
+                <a:ea typeface="맑은 고딕" pitchFamily="34" charset="-122"/>
+                <a:cs typeface="맑은 고딕" pitchFamily="34" charset="-120"/>
+              </a:rPr>
+              <a:t>Partnership</a:t>
+            </a:r>
+            <a:endParaRPr lang="en-US" sz="1300" dirty="0"/>
+          </a:p>
+        </p:txBody>
+      </p:sp>
+      <p:sp>
+        <p:nvSpPr>
+          <p:cNvPr id="29" name="Shape 27"/>
           <p:cNvSpPr/>
           <p:nvPr/>
         </p:nvSpPr>
         <p:spPr>
           <a:xfrm>
-            <a:off x="6336792" y="2240280"/>
-            <a:ext cx="5486400" cy="1691640"/>
-          </a:xfrm>
-          <a:prstGeom prst="rect">
-            <a:avLst/>
-          </a:prstGeom>
-          <a:solidFill>
-            <a:srgbClr val="F5F7FA"/>
+            <a:off x="685800" y="4846320"/>
+            <a:ext cx="1463040" cy="1463040"/>
+          </a:xfrm>
+          <a:prstGeom prst="ellipse">
+            <a:avLst/>
+          </a:prstGeom>
+          <a:solidFill>
+            <a:srgbClr val="F4DCDC"/>
           </a:solidFill>
           <a:ln w="12700">
             <a:solidFill>
-              <a:srgbClr val="F5F7FA"/>
+              <a:srgbClr val="F4DCDC"/>
             </a:solidFill>
             <a:prstDash val="solid"/>
           </a:ln>
@@ -2102,63 +1937,78 @@
       </p:sp>
       <p:sp>
         <p:nvSpPr>
-          <p:cNvPr id="37" name="Shape 33"/>
+          <p:cNvPr id="30" name="Text 28"/>
+          <p:cNvSpPr txBox="1"/>
+          <p:nvPr/>
+        </p:nvSpPr>
+        <p:spPr>
+          <a:xfrm>
+            <a:off x="685800" y="4846320"/>
+            <a:ext cx="1463040" cy="1463040"/>
+          </a:xfrm>
+          <a:prstGeom prst="rect">
+            <a:avLst/>
+          </a:prstGeom>
+          <a:noFill/>
+          <a:ln/>
+        </p:spPr>
+        <p:txBody>
+          <a:bodyPr wrap="square" lIns="0" tIns="0" rIns="0" bIns="0" rtlCol="0" anchor="ctr"/>
+          <a:lstStyle/>
+          <a:p>
+            <a:pPr algn="ctr" indent="0" marL="0">
+              <a:buNone/>
+            </a:pPr>
+            <a:r>
+              <a:rPr lang="en-US" sz="1800" b="1" dirty="0">
+                <a:solidFill>
+                  <a:srgbClr val="262626"/>
+                </a:solidFill>
+                <a:latin typeface="맑은 고딕" pitchFamily="34" charset="0"/>
+                <a:ea typeface="맑은 고딕" pitchFamily="34" charset="-122"/>
+                <a:cs typeface="맑은 고딕" pitchFamily="34" charset="-120"/>
+              </a:rPr>
+              <a:t>IS팀</a:t>
+            </a:r>
+            <a:endParaRPr lang="en-US" sz="1800" dirty="0"/>
+          </a:p>
+        </p:txBody>
+      </p:sp>
+      <p:sp>
+        <p:nvSpPr>
+          <p:cNvPr id="31" name="Shape 29"/>
           <p:cNvSpPr/>
           <p:nvPr/>
         </p:nvSpPr>
         <p:spPr>
           <a:xfrm>
-            <a:off x="6565392" y="2377440"/>
-            <a:ext cx="868680" cy="868680"/>
+            <a:off x="4160520" y="4297680"/>
+            <a:ext cx="1463040" cy="1463040"/>
           </a:xfrm>
           <a:prstGeom prst="ellipse">
             <a:avLst/>
           </a:prstGeom>
           <a:solidFill>
-            <a:srgbClr val="243F60"/>
+            <a:srgbClr val="DAE3F3"/>
           </a:solidFill>
           <a:ln w="12700">
             <a:solidFill>
-              <a:srgbClr val="243F60"/>
+              <a:srgbClr val="DAE3F3"/>
             </a:solidFill>
             <a:prstDash val="solid"/>
           </a:ln>
         </p:spPr>
       </p:sp>
-      <p:pic>
-        <p:nvPicPr>
-          <p:cNvPr id="38" name="Image 2" descr="preencoded.png">    </p:cNvPr>
-          <p:cNvPicPr>
-            <a:picLocks noChangeAspect="1"/>
-          </p:cNvPicPr>
-          <p:nvPr/>
-        </p:nvPicPr>
-        <p:blipFill>
-          <a:blip r:embed="rId3"/>
-          <a:stretch>
-            <a:fillRect/>
-          </a:stretch>
-        </p:blipFill>
-        <p:spPr>
-          <a:xfrm>
-            <a:off x="6784848" y="2596896"/>
-            <a:ext cx="429768" cy="429768"/>
-          </a:xfrm>
-          <a:prstGeom prst="rect">
-            <a:avLst/>
-          </a:prstGeom>
-        </p:spPr>
-      </p:pic>
-      <p:sp>
-        <p:nvSpPr>
-          <p:cNvPr id="39" name="Text 34"/>
+      <p:sp>
+        <p:nvSpPr>
+          <p:cNvPr id="32" name="Text 30"/>
           <p:cNvSpPr txBox="1"/>
           <p:nvPr/>
         </p:nvSpPr>
         <p:spPr>
           <a:xfrm>
-            <a:off x="6291072" y="3291840"/>
-            <a:ext cx="1417320" cy="274320"/>
+            <a:off x="4160520" y="4297680"/>
+            <a:ext cx="1463040" cy="1463040"/>
           </a:xfrm>
           <a:prstGeom prst="rect">
             <a:avLst/>
@@ -2174,7 +2024,7 @@
               <a:buNone/>
             </a:pPr>
             <a:r>
-              <a:rPr lang="en-US" sz="1200" b="1" dirty="0">
+              <a:rPr lang="en-US" sz="1800" b="1" dirty="0">
                 <a:solidFill>
                   <a:srgbClr val="262626"/>
                 </a:solidFill>
@@ -2182,120 +2032,76 @@
                 <a:ea typeface="맑은 고딕" pitchFamily="34" charset="-122"/>
                 <a:cs typeface="맑은 고딕" pitchFamily="34" charset="-120"/>
               </a:rPr>
-              <a:t>AX컨설팅팀</a:t>
-            </a:r>
-            <a:endParaRPr lang="en-US" sz="1200" dirty="0"/>
-          </a:p>
-        </p:txBody>
-      </p:sp>
-      <p:sp>
-        <p:nvSpPr>
-          <p:cNvPr id="40" name="Shape 35"/>
+              <a:t>AI</a:t>
+            </a:r>
+            <a:endParaRPr lang="en-US" sz="1800" dirty="0"/>
+          </a:p>
+          <a:p>
+            <a:pPr algn="ctr" indent="0" marL="0">
+              <a:buNone/>
+            </a:pPr>
+            <a:r>
+              <a:rPr lang="en-US" sz="1800" b="1" dirty="0">
+                <a:solidFill>
+                  <a:srgbClr val="262626"/>
+                </a:solidFill>
+                <a:latin typeface="맑은 고딕" pitchFamily="34" charset="0"/>
+                <a:ea typeface="맑은 고딕" pitchFamily="34" charset="-122"/>
+                <a:cs typeface="맑은 고딕" pitchFamily="34" charset="-120"/>
+              </a:rPr>
+              <a:t>혁신센터</a:t>
+            </a:r>
+            <a:endParaRPr lang="en-US" sz="1800" dirty="0"/>
+          </a:p>
+        </p:txBody>
+      </p:sp>
+      <p:sp>
+        <p:nvSpPr>
+          <p:cNvPr id="33" name="Shape 31"/>
           <p:cNvSpPr/>
           <p:nvPr/>
         </p:nvSpPr>
         <p:spPr>
           <a:xfrm>
-            <a:off x="10725912" y="2377440"/>
-            <a:ext cx="868680" cy="868680"/>
-          </a:xfrm>
-          <a:prstGeom prst="ellipse">
-            <a:avLst/>
-          </a:prstGeom>
-          <a:solidFill>
-            <a:srgbClr val="4A7BC8"/>
+            <a:off x="6217920" y="1737360"/>
+            <a:ext cx="5669280" cy="4892040"/>
+          </a:xfrm>
+          <a:prstGeom prst="rect">
+            <a:avLst/>
+          </a:prstGeom>
+          <a:solidFill>
+            <a:srgbClr val="FFFFFF"/>
           </a:solidFill>
           <a:ln w="12700">
             <a:solidFill>
-              <a:srgbClr val="4A7BC8"/>
+              <a:srgbClr val="A6A6A6"/>
             </a:solidFill>
             <a:prstDash val="solid"/>
           </a:ln>
         </p:spPr>
       </p:sp>
-      <p:pic>
-        <p:nvPicPr>
-          <p:cNvPr id="41" name="Image 3" descr="preencoded.png">    </p:cNvPr>
-          <p:cNvPicPr>
-            <a:picLocks noChangeAspect="1"/>
-          </p:cNvPicPr>
-          <p:nvPr/>
-        </p:nvPicPr>
-        <p:blipFill>
-          <a:blip r:embed="rId4"/>
-          <a:stretch>
-            <a:fillRect/>
-          </a:stretch>
-        </p:blipFill>
-        <p:spPr>
-          <a:xfrm>
-            <a:off x="10945368" y="2596896"/>
-            <a:ext cx="429768" cy="429768"/>
-          </a:xfrm>
-          <a:prstGeom prst="rect">
-            <a:avLst/>
-          </a:prstGeom>
-        </p:spPr>
-      </p:pic>
-      <p:sp>
-        <p:nvSpPr>
-          <p:cNvPr id="42" name="Text 36"/>
-          <p:cNvSpPr txBox="1"/>
-          <p:nvPr/>
-        </p:nvSpPr>
-        <p:spPr>
-          <a:xfrm>
-            <a:off x="10451592" y="3291840"/>
-            <a:ext cx="1417320" cy="274320"/>
-          </a:xfrm>
-          <a:prstGeom prst="rect">
-            <a:avLst/>
-          </a:prstGeom>
-          <a:noFill/>
-          <a:ln/>
-        </p:spPr>
-        <p:txBody>
-          <a:bodyPr wrap="square" lIns="0" tIns="0" rIns="0" bIns="0" rtlCol="0" anchor="ctr"/>
-          <a:lstStyle/>
-          <a:p>
-            <a:pPr algn="ctr" indent="0" marL="0">
-              <a:buNone/>
-            </a:pPr>
-            <a:r>
-              <a:rPr lang="en-US" sz="1200" b="1" dirty="0">
-                <a:solidFill>
-                  <a:srgbClr val="262626"/>
-                </a:solidFill>
-                <a:latin typeface="맑은 고딕" pitchFamily="34" charset="0"/>
-                <a:ea typeface="맑은 고딕" pitchFamily="34" charset="-122"/>
-                <a:cs typeface="맑은 고딕" pitchFamily="34" charset="-120"/>
-              </a:rPr>
-              <a:t>현업</a:t>
-            </a:r>
-            <a:endParaRPr lang="en-US" sz="1200" dirty="0"/>
-          </a:p>
-        </p:txBody>
-      </p:sp>
-      <p:sp>
-        <p:nvSpPr>
-          <p:cNvPr id="43" name="Shape 37"/>
+      <p:sp>
+        <p:nvSpPr>
+          <p:cNvPr id="34" name="Shape 32"/>
           <p:cNvSpPr/>
           <p:nvPr/>
         </p:nvSpPr>
         <p:spPr>
           <a:xfrm>
-            <a:off x="7571232" y="2587752"/>
-            <a:ext cx="987552" cy="457200"/>
-          </a:xfrm>
-          <a:prstGeom prst="homePlate">
-            <a:avLst/>
-          </a:prstGeom>
-          <a:solidFill>
-            <a:srgbClr val="8FAADC"/>
+            <a:off x="6446520" y="1307592"/>
+            <a:ext cx="5212080" cy="429768"/>
+          </a:xfrm>
+          <a:prstGeom prst="round2SameRect">
+            <a:avLst>
+              <a:gd name="adj" fmla="val 17021"/>
+            </a:avLst>
+          </a:prstGeom>
+          <a:solidFill>
+            <a:srgbClr val="404040"/>
           </a:solidFill>
           <a:ln w="12700">
             <a:solidFill>
-              <a:srgbClr val="8FAADC"/>
+              <a:srgbClr val="404040"/>
             </a:solidFill>
             <a:prstDash val="solid"/>
           </a:ln>
@@ -2303,14 +2109,14 @@
       </p:sp>
       <p:sp>
         <p:nvSpPr>
-          <p:cNvPr id="44" name="Text 38"/>
+          <p:cNvPr id="35" name="Text 33"/>
           <p:cNvSpPr txBox="1"/>
           <p:nvPr/>
         </p:nvSpPr>
         <p:spPr>
           <a:xfrm>
-            <a:off x="7662672" y="2587752"/>
-            <a:ext cx="804672" cy="457200"/>
+            <a:off x="6446520" y="1307592"/>
+            <a:ext cx="5212080" cy="429768"/>
           </a:xfrm>
           <a:prstGeom prst="rect">
             <a:avLst/>
@@ -2326,7 +2132,7 @@
               <a:buNone/>
             </a:pPr>
             <a:r>
-              <a:rPr lang="en-US" sz="1150" b="1" dirty="0">
+              <a:rPr lang="en-US" sz="1700" b="1" dirty="0">
                 <a:solidFill>
                   <a:srgbClr val="FFFFFF"/>
                 </a:solidFill>
@@ -2334,32 +2140,88 @@
                 <a:ea typeface="맑은 고딕" pitchFamily="34" charset="-122"/>
                 <a:cs typeface="맑은 고딕" pitchFamily="34" charset="-120"/>
               </a:rPr>
-              <a:t>교육</a:t>
-            </a:r>
-            <a:endParaRPr lang="en-US" sz="1150" dirty="0"/>
-          </a:p>
-        </p:txBody>
-      </p:sp>
-      <p:sp>
-        <p:nvSpPr>
-          <p:cNvPr id="45" name="Shape 39"/>
+              <a:t>② 현업 Use case 발굴 교육·워크샵</a:t>
+            </a:r>
+            <a:endParaRPr lang="en-US" sz="1700" dirty="0"/>
+          </a:p>
+        </p:txBody>
+      </p:sp>
+      <p:sp>
+        <p:nvSpPr>
+          <p:cNvPr id="36" name="Text 34"/>
+          <p:cNvSpPr txBox="1"/>
+          <p:nvPr/>
+        </p:nvSpPr>
+        <p:spPr>
+          <a:xfrm>
+            <a:off x="6355080" y="1965960"/>
+            <a:ext cx="548640" cy="685800"/>
+          </a:xfrm>
+          <a:prstGeom prst="rect">
+            <a:avLst/>
+          </a:prstGeom>
+          <a:noFill/>
+          <a:ln/>
+        </p:spPr>
+        <p:txBody>
+          <a:bodyPr wrap="square" lIns="0" tIns="0" rIns="0" bIns="0" rtlCol="0" anchor="ctr"/>
+          <a:lstStyle/>
+          <a:p>
+            <a:pPr algn="ctr" indent="0" marL="0">
+              <a:buNone/>
+            </a:pPr>
+            <a:r>
+              <a:rPr lang="en-US" sz="1200" b="1" dirty="0">
+                <a:solidFill>
+                  <a:srgbClr val="7F7F7F"/>
+                </a:solidFill>
+                <a:latin typeface="맑은 고딕" pitchFamily="34" charset="0"/>
+                <a:ea typeface="맑은 고딕" pitchFamily="34" charset="-122"/>
+                <a:cs typeface="맑은 고딕" pitchFamily="34" charset="-120"/>
+              </a:rPr>
+              <a:t>추진</a:t>
+            </a:r>
+            <a:endParaRPr lang="en-US" sz="1200" dirty="0"/>
+          </a:p>
+          <a:p>
+            <a:pPr algn="ctr" indent="0" marL="0">
+              <a:buNone/>
+            </a:pPr>
+            <a:r>
+              <a:rPr lang="en-US" sz="1200" b="1" dirty="0">
+                <a:solidFill>
+                  <a:srgbClr val="7F7F7F"/>
+                </a:solidFill>
+                <a:latin typeface="맑은 고딕" pitchFamily="34" charset="0"/>
+                <a:ea typeface="맑은 고딕" pitchFamily="34" charset="-122"/>
+                <a:cs typeface="맑은 고딕" pitchFamily="34" charset="-120"/>
+              </a:rPr>
+              <a:t>과정</a:t>
+            </a:r>
+            <a:endParaRPr lang="en-US" sz="1200" dirty="0"/>
+          </a:p>
+        </p:txBody>
+      </p:sp>
+      <p:sp>
+        <p:nvSpPr>
+          <p:cNvPr id="37" name="Shape 35"/>
           <p:cNvSpPr/>
           <p:nvPr/>
         </p:nvSpPr>
         <p:spPr>
           <a:xfrm>
-            <a:off x="8586216" y="2587752"/>
-            <a:ext cx="987552" cy="457200"/>
-          </a:xfrm>
-          <a:prstGeom prst="chevron">
-            <a:avLst/>
-          </a:prstGeom>
-          <a:solidFill>
-            <a:srgbClr val="4A7BC8"/>
+            <a:off x="6949440" y="1965960"/>
+            <a:ext cx="1600200" cy="685800"/>
+          </a:xfrm>
+          <a:prstGeom prst="homePlate">
+            <a:avLst/>
+          </a:prstGeom>
+          <a:solidFill>
+            <a:srgbClr val="EEF1F7"/>
           </a:solidFill>
           <a:ln w="12700">
             <a:solidFill>
-              <a:srgbClr val="4A7BC8"/>
+              <a:srgbClr val="B4C0D6"/>
             </a:solidFill>
             <a:prstDash val="solid"/>
           </a:ln>
@@ -2367,14 +2229,14 @@
       </p:sp>
       <p:sp>
         <p:nvSpPr>
-          <p:cNvPr id="46" name="Text 40"/>
+          <p:cNvPr id="38" name="Text 36"/>
           <p:cNvSpPr txBox="1"/>
           <p:nvPr/>
         </p:nvSpPr>
         <p:spPr>
           <a:xfrm>
-            <a:off x="8677656" y="2587752"/>
-            <a:ext cx="804672" cy="457200"/>
+            <a:off x="7040880" y="1965960"/>
+            <a:ext cx="1097280" cy="685800"/>
           </a:xfrm>
           <a:prstGeom prst="rect">
             <a:avLst/>
@@ -2390,40 +2252,57 @@
               <a:buNone/>
             </a:pPr>
             <a:r>
-              <a:rPr lang="en-US" sz="1150" b="1" dirty="0">
-                <a:solidFill>
-                  <a:srgbClr val="FFFFFF"/>
-                </a:solidFill>
-                <a:latin typeface="맑은 고딕" pitchFamily="34" charset="0"/>
-                <a:ea typeface="맑은 고딕" pitchFamily="34" charset="-122"/>
-                <a:cs typeface="맑은 고딕" pitchFamily="34" charset="-120"/>
-              </a:rPr>
-              <a:t>워크샵</a:t>
-            </a:r>
-            <a:endParaRPr lang="en-US" sz="1150" dirty="0"/>
-          </a:p>
-        </p:txBody>
-      </p:sp>
-      <p:sp>
-        <p:nvSpPr>
-          <p:cNvPr id="47" name="Shape 41"/>
+              <a:rPr lang="en-US" sz="1200" b="1" dirty="0">
+                <a:solidFill>
+                  <a:srgbClr val="262626"/>
+                </a:solidFill>
+                <a:latin typeface="맑은 고딕" pitchFamily="34" charset="0"/>
+                <a:ea typeface="맑은 고딕" pitchFamily="34" charset="-122"/>
+                <a:cs typeface="맑은 고딕" pitchFamily="34" charset="-120"/>
+              </a:rPr>
+              <a:t>AI Agent</a:t>
+            </a:r>
+            <a:endParaRPr lang="en-US" sz="1200" dirty="0"/>
+          </a:p>
+          <a:p>
+            <a:pPr algn="ctr" indent="0" marL="0">
+              <a:buNone/>
+            </a:pPr>
+            <a:r>
+              <a:rPr lang="en-US" sz="1200" b="1" dirty="0">
+                <a:solidFill>
+                  <a:srgbClr val="262626"/>
+                </a:solidFill>
+                <a:latin typeface="맑은 고딕" pitchFamily="34" charset="0"/>
+                <a:ea typeface="맑은 고딕" pitchFamily="34" charset="-122"/>
+                <a:cs typeface="맑은 고딕" pitchFamily="34" charset="-120"/>
+              </a:rPr>
+              <a:t>이해 교육</a:t>
+            </a:r>
+            <a:endParaRPr lang="en-US" sz="1200" dirty="0"/>
+          </a:p>
+        </p:txBody>
+      </p:sp>
+      <p:sp>
+        <p:nvSpPr>
+          <p:cNvPr id="39" name="Shape 37"/>
           <p:cNvSpPr/>
           <p:nvPr/>
         </p:nvSpPr>
         <p:spPr>
           <a:xfrm>
-            <a:off x="9601200" y="2587752"/>
-            <a:ext cx="987552" cy="457200"/>
-          </a:xfrm>
-          <a:prstGeom prst="chevron">
-            <a:avLst/>
-          </a:prstGeom>
-          <a:solidFill>
-            <a:srgbClr val="243F60"/>
+            <a:off x="6967728" y="1828800"/>
+            <a:ext cx="246888" cy="246888"/>
+          </a:xfrm>
+          <a:prstGeom prst="rect">
+            <a:avLst/>
+          </a:prstGeom>
+          <a:solidFill>
+            <a:srgbClr val="7F7F7F"/>
           </a:solidFill>
           <a:ln w="12700">
             <a:solidFill>
-              <a:srgbClr val="243F60"/>
+              <a:srgbClr val="7F7F7F"/>
             </a:solidFill>
             <a:prstDash val="solid"/>
           </a:ln>
@@ -2431,14 +2310,14 @@
       </p:sp>
       <p:sp>
         <p:nvSpPr>
-          <p:cNvPr id="48" name="Text 42"/>
+          <p:cNvPr id="40" name="Text 38"/>
           <p:cNvSpPr txBox="1"/>
           <p:nvPr/>
         </p:nvSpPr>
         <p:spPr>
           <a:xfrm>
-            <a:off x="9692640" y="2587752"/>
-            <a:ext cx="804672" cy="457200"/>
+            <a:off x="6967728" y="1828800"/>
+            <a:ext cx="246888" cy="246888"/>
           </a:xfrm>
           <a:prstGeom prst="rect">
             <a:avLst/>
@@ -2454,7 +2333,7 @@
               <a:buNone/>
             </a:pPr>
             <a:r>
-              <a:rPr lang="en-US" sz="1150" b="1" dirty="0">
+              <a:rPr lang="en-US" sz="1100" b="1" dirty="0">
                 <a:solidFill>
                   <a:srgbClr val="FFFFFF"/>
                 </a:solidFill>
@@ -2462,46 +2341,7 @@
                 <a:ea typeface="맑은 고딕" pitchFamily="34" charset="-122"/>
                 <a:cs typeface="맑은 고딕" pitchFamily="34" charset="-120"/>
               </a:rPr>
-              <a:t>과제화</a:t>
-            </a:r>
-            <a:endParaRPr lang="en-US" sz="1150" dirty="0"/>
-          </a:p>
-        </p:txBody>
-      </p:sp>
-      <p:sp>
-        <p:nvSpPr>
-          <p:cNvPr id="49" name="Text 43"/>
-          <p:cNvSpPr txBox="1"/>
-          <p:nvPr/>
-        </p:nvSpPr>
-        <p:spPr>
-          <a:xfrm>
-            <a:off x="6336792" y="3611880"/>
-            <a:ext cx="5486400" cy="256032"/>
-          </a:xfrm>
-          <a:prstGeom prst="rect">
-            <a:avLst/>
-          </a:prstGeom>
-          <a:noFill/>
-          <a:ln/>
-        </p:spPr>
-        <p:txBody>
-          <a:bodyPr wrap="square" lIns="0" tIns="0" rIns="0" bIns="0" rtlCol="0" anchor="ctr"/>
-          <a:lstStyle/>
-          <a:p>
-            <a:pPr algn="ctr" indent="0" marL="0">
-              <a:buNone/>
-            </a:pPr>
-            <a:r>
-              <a:rPr lang="en-US" sz="1100" i="1" dirty="0">
-                <a:solidFill>
-                  <a:srgbClr val="595959"/>
-                </a:solidFill>
-                <a:latin typeface="맑은 고딕" pitchFamily="34" charset="0"/>
-                <a:ea typeface="맑은 고딕" pitchFamily="34" charset="-122"/>
-                <a:cs typeface="맑은 고딕" pitchFamily="34" charset="-120"/>
-              </a:rPr>
-              <a:t>현업이 직접 Agent 과제를 발굴하는 역량 확보</a:t>
+              <a:t>1</a:t>
             </a:r>
             <a:endParaRPr lang="en-US" sz="1100" dirty="0"/>
           </a:p>
@@ -2509,24 +2349,24 @@
       </p:sp>
       <p:sp>
         <p:nvSpPr>
-          <p:cNvPr id="50" name="Shape 44"/>
+          <p:cNvPr id="41" name="Shape 39"/>
           <p:cNvSpPr/>
           <p:nvPr/>
         </p:nvSpPr>
         <p:spPr>
           <a:xfrm>
-            <a:off x="6473952" y="4133088"/>
-            <a:ext cx="274320" cy="274320"/>
-          </a:xfrm>
-          <a:prstGeom prst="ellipse">
-            <a:avLst/>
-          </a:prstGeom>
-          <a:solidFill>
-            <a:srgbClr val="4A7BC8"/>
+            <a:off x="8503920" y="1965960"/>
+            <a:ext cx="1600200" cy="685800"/>
+          </a:xfrm>
+          <a:prstGeom prst="chevron">
+            <a:avLst/>
+          </a:prstGeom>
+          <a:solidFill>
+            <a:srgbClr val="EEF1F7"/>
           </a:solidFill>
           <a:ln w="12700">
             <a:solidFill>
-              <a:srgbClr val="4A7BC8"/>
+              <a:srgbClr val="B4C0D6"/>
             </a:solidFill>
             <a:prstDash val="solid"/>
           </a:ln>
@@ -2534,14 +2374,14 @@
       </p:sp>
       <p:sp>
         <p:nvSpPr>
-          <p:cNvPr id="51" name="Text 45"/>
+          <p:cNvPr id="42" name="Text 40"/>
           <p:cNvSpPr txBox="1"/>
           <p:nvPr/>
         </p:nvSpPr>
         <p:spPr>
           <a:xfrm>
-            <a:off x="6473952" y="4133088"/>
-            <a:ext cx="274320" cy="274320"/>
+            <a:off x="8778240" y="1965960"/>
+            <a:ext cx="1097280" cy="685800"/>
           </a:xfrm>
           <a:prstGeom prst="rect">
             <a:avLst/>
@@ -2557,46 +2397,7 @@
               <a:buNone/>
             </a:pPr>
             <a:r>
-              <a:rPr lang="en-US" sz="1100" b="1" dirty="0">
-                <a:solidFill>
-                  <a:srgbClr val="FFFFFF"/>
-                </a:solidFill>
-                <a:latin typeface="맑은 고딕" pitchFamily="34" charset="0"/>
-                <a:ea typeface="맑은 고딕" pitchFamily="34" charset="-122"/>
-                <a:cs typeface="맑은 고딕" pitchFamily="34" charset="-120"/>
-              </a:rPr>
-              <a:t>1</a:t>
-            </a:r>
-            <a:endParaRPr lang="en-US" sz="1100" dirty="0"/>
-          </a:p>
-        </p:txBody>
-      </p:sp>
-      <p:sp>
-        <p:nvSpPr>
-          <p:cNvPr id="52" name="Text 46"/>
-          <p:cNvSpPr txBox="1"/>
-          <p:nvPr/>
-        </p:nvSpPr>
-        <p:spPr>
-          <a:xfrm>
-            <a:off x="6885432" y="4041648"/>
-            <a:ext cx="4846320" cy="475488"/>
-          </a:xfrm>
-          <a:prstGeom prst="rect">
-            <a:avLst/>
-          </a:prstGeom>
-          <a:noFill/>
-          <a:ln/>
-        </p:spPr>
-        <p:txBody>
-          <a:bodyPr wrap="square" lIns="0" tIns="0" rIns="0" bIns="0" rtlCol="0" anchor="ctr"/>
-          <a:lstStyle/>
-          <a:p>
-            <a:pPr indent="0" marL="0">
-              <a:buNone/>
-            </a:pPr>
-            <a:r>
-              <a:rPr lang="en-US" sz="1300" b="1" dirty="0">
+              <a:rPr lang="en-US" sz="1200" b="1" dirty="0">
                 <a:solidFill>
                   <a:srgbClr val="262626"/>
                 </a:solidFill>
@@ -2604,49 +2405,49 @@
                 <a:ea typeface="맑은 고딕" pitchFamily="34" charset="-122"/>
                 <a:cs typeface="맑은 고딕" pitchFamily="34" charset="-120"/>
               </a:rPr>
-              <a:t>AI Agent 이해 교육</a:t>
-            </a:r>
-            <a:endParaRPr lang="en-US" sz="1300" dirty="0"/>
-          </a:p>
-          <a:p>
-            <a:pPr indent="0" marL="0">
-              <a:buNone/>
-            </a:pPr>
-            <a:r>
-              <a:rPr lang="en-US" sz="1100" dirty="0">
-                <a:solidFill>
-                  <a:srgbClr val="595959"/>
-                </a:solidFill>
-                <a:latin typeface="맑은 고딕" pitchFamily="34" charset="0"/>
-                <a:ea typeface="맑은 고딕" pitchFamily="34" charset="-122"/>
-                <a:cs typeface="맑은 고딕" pitchFamily="34" charset="-120"/>
-              </a:rPr>
-              <a:t>Agent 개념·적용 사례, Agent 적용이 가능한 업무 유형</a:t>
-            </a:r>
-            <a:endParaRPr lang="en-US" sz="1300" dirty="0"/>
-          </a:p>
-        </p:txBody>
-      </p:sp>
-      <p:sp>
-        <p:nvSpPr>
-          <p:cNvPr id="53" name="Shape 47"/>
+              <a:t>Use case</a:t>
+            </a:r>
+            <a:endParaRPr lang="en-US" sz="1200" dirty="0"/>
+          </a:p>
+          <a:p>
+            <a:pPr algn="ctr" indent="0" marL="0">
+              <a:buNone/>
+            </a:pPr>
+            <a:r>
+              <a:rPr lang="en-US" sz="1200" b="1" dirty="0">
+                <a:solidFill>
+                  <a:srgbClr val="262626"/>
+                </a:solidFill>
+                <a:latin typeface="맑은 고딕" pitchFamily="34" charset="0"/>
+                <a:ea typeface="맑은 고딕" pitchFamily="34" charset="-122"/>
+                <a:cs typeface="맑은 고딕" pitchFamily="34" charset="-120"/>
+              </a:rPr>
+              <a:t>발굴 워크샵</a:t>
+            </a:r>
+            <a:endParaRPr lang="en-US" sz="1200" dirty="0"/>
+          </a:p>
+        </p:txBody>
+      </p:sp>
+      <p:sp>
+        <p:nvSpPr>
+          <p:cNvPr id="43" name="Shape 41"/>
           <p:cNvSpPr/>
           <p:nvPr/>
         </p:nvSpPr>
         <p:spPr>
           <a:xfrm>
-            <a:off x="6473952" y="4608576"/>
-            <a:ext cx="274320" cy="274320"/>
-          </a:xfrm>
-          <a:prstGeom prst="ellipse">
-            <a:avLst/>
-          </a:prstGeom>
-          <a:solidFill>
-            <a:srgbClr val="4A7BC8"/>
+            <a:off x="8522208" y="1828800"/>
+            <a:ext cx="246888" cy="246888"/>
+          </a:xfrm>
+          <a:prstGeom prst="rect">
+            <a:avLst/>
+          </a:prstGeom>
+          <a:solidFill>
+            <a:srgbClr val="7F7F7F"/>
           </a:solidFill>
           <a:ln w="12700">
             <a:solidFill>
-              <a:srgbClr val="4A7BC8"/>
+              <a:srgbClr val="7F7F7F"/>
             </a:solidFill>
             <a:prstDash val="solid"/>
           </a:ln>
@@ -2654,14 +2455,14 @@
       </p:sp>
       <p:sp>
         <p:nvSpPr>
-          <p:cNvPr id="54" name="Text 48"/>
+          <p:cNvPr id="44" name="Text 42"/>
           <p:cNvSpPr txBox="1"/>
           <p:nvPr/>
         </p:nvSpPr>
         <p:spPr>
           <a:xfrm>
-            <a:off x="6473952" y="4608576"/>
-            <a:ext cx="274320" cy="274320"/>
+            <a:off x="8522208" y="1828800"/>
+            <a:ext cx="246888" cy="246888"/>
           </a:xfrm>
           <a:prstGeom prst="rect">
             <a:avLst/>
@@ -2693,80 +2494,24 @@
       </p:sp>
       <p:sp>
         <p:nvSpPr>
-          <p:cNvPr id="55" name="Text 49"/>
-          <p:cNvSpPr txBox="1"/>
-          <p:nvPr/>
-        </p:nvSpPr>
-        <p:spPr>
-          <a:xfrm>
-            <a:off x="6885432" y="4517136"/>
-            <a:ext cx="4846320" cy="475488"/>
-          </a:xfrm>
-          <a:prstGeom prst="rect">
-            <a:avLst/>
-          </a:prstGeom>
-          <a:noFill/>
-          <a:ln/>
-        </p:spPr>
-        <p:txBody>
-          <a:bodyPr wrap="square" lIns="0" tIns="0" rIns="0" bIns="0" rtlCol="0" anchor="ctr"/>
-          <a:lstStyle/>
-          <a:p>
-            <a:pPr indent="0" marL="0">
-              <a:buNone/>
-            </a:pPr>
-            <a:r>
-              <a:rPr lang="en-US" sz="1300" b="1" dirty="0">
-                <a:solidFill>
-                  <a:srgbClr val="262626"/>
-                </a:solidFill>
-                <a:latin typeface="맑은 고딕" pitchFamily="34" charset="0"/>
-                <a:ea typeface="맑은 고딕" pitchFamily="34" charset="-122"/>
-                <a:cs typeface="맑은 고딕" pitchFamily="34" charset="-120"/>
-              </a:rPr>
-              <a:t>Use case 발굴 방법론</a:t>
-            </a:r>
-            <a:endParaRPr lang="en-US" sz="1300" dirty="0"/>
-          </a:p>
-          <a:p>
-            <a:pPr indent="0" marL="0">
-              <a:buNone/>
-            </a:pPr>
-            <a:r>
-              <a:rPr lang="en-US" sz="1100" dirty="0">
-                <a:solidFill>
-                  <a:srgbClr val="595959"/>
-                </a:solidFill>
-                <a:latin typeface="맑은 고딕" pitchFamily="34" charset="0"/>
-                <a:ea typeface="맑은 고딕" pitchFamily="34" charset="-122"/>
-                <a:cs typeface="맑은 고딕" pitchFamily="34" charset="-120"/>
-              </a:rPr>
-              <a:t>Pain Point 도출 → 업무 분해 → Agent 적합성 체크리스트</a:t>
-            </a:r>
-            <a:endParaRPr lang="en-US" sz="1300" dirty="0"/>
-          </a:p>
-        </p:txBody>
-      </p:sp>
-      <p:sp>
-        <p:nvSpPr>
-          <p:cNvPr id="56" name="Shape 50"/>
+          <p:cNvPr id="45" name="Shape 43"/>
           <p:cNvSpPr/>
           <p:nvPr/>
         </p:nvSpPr>
         <p:spPr>
           <a:xfrm>
-            <a:off x="6473952" y="5084064"/>
-            <a:ext cx="274320" cy="274320"/>
-          </a:xfrm>
-          <a:prstGeom prst="ellipse">
-            <a:avLst/>
-          </a:prstGeom>
-          <a:solidFill>
-            <a:srgbClr val="4A7BC8"/>
+            <a:off x="10058400" y="1965960"/>
+            <a:ext cx="1600200" cy="685800"/>
+          </a:xfrm>
+          <a:prstGeom prst="chevron">
+            <a:avLst/>
+          </a:prstGeom>
+          <a:solidFill>
+            <a:srgbClr val="EEF1F7"/>
           </a:solidFill>
           <a:ln w="12700">
             <a:solidFill>
-              <a:srgbClr val="4A7BC8"/>
+              <a:srgbClr val="B4C0D6"/>
             </a:solidFill>
             <a:prstDash val="solid"/>
           </a:ln>
@@ -2774,14 +2519,14 @@
       </p:sp>
       <p:sp>
         <p:nvSpPr>
-          <p:cNvPr id="57" name="Text 51"/>
+          <p:cNvPr id="46" name="Text 44"/>
           <p:cNvSpPr txBox="1"/>
           <p:nvPr/>
         </p:nvSpPr>
         <p:spPr>
           <a:xfrm>
-            <a:off x="6473952" y="5084064"/>
-            <a:ext cx="274320" cy="274320"/>
+            <a:off x="10332720" y="1965960"/>
+            <a:ext cx="1097280" cy="685800"/>
           </a:xfrm>
           <a:prstGeom prst="rect">
             <a:avLst/>
@@ -2797,46 +2542,7 @@
               <a:buNone/>
             </a:pPr>
             <a:r>
-              <a:rPr lang="en-US" sz="1100" b="1" dirty="0">
-                <a:solidFill>
-                  <a:srgbClr val="FFFFFF"/>
-                </a:solidFill>
-                <a:latin typeface="맑은 고딕" pitchFamily="34" charset="0"/>
-                <a:ea typeface="맑은 고딕" pitchFamily="34" charset="-122"/>
-                <a:cs typeface="맑은 고딕" pitchFamily="34" charset="-120"/>
-              </a:rPr>
-              <a:t>3</a:t>
-            </a:r>
-            <a:endParaRPr lang="en-US" sz="1100" dirty="0"/>
-          </a:p>
-        </p:txBody>
-      </p:sp>
-      <p:sp>
-        <p:nvSpPr>
-          <p:cNvPr id="58" name="Text 52"/>
-          <p:cNvSpPr txBox="1"/>
-          <p:nvPr/>
-        </p:nvSpPr>
-        <p:spPr>
-          <a:xfrm>
-            <a:off x="6885432" y="4992624"/>
-            <a:ext cx="4846320" cy="475488"/>
-          </a:xfrm>
-          <a:prstGeom prst="rect">
-            <a:avLst/>
-          </a:prstGeom>
-          <a:noFill/>
-          <a:ln/>
-        </p:spPr>
-        <p:txBody>
-          <a:bodyPr wrap="square" lIns="0" tIns="0" rIns="0" bIns="0" rtlCol="0" anchor="ctr"/>
-          <a:lstStyle/>
-          <a:p>
-            <a:pPr indent="0" marL="0">
-              <a:buNone/>
-            </a:pPr>
-            <a:r>
-              <a:rPr lang="en-US" sz="1300" b="1" dirty="0">
+              <a:rPr lang="en-US" sz="1200" b="1" dirty="0">
                 <a:solidFill>
                   <a:srgbClr val="262626"/>
                 </a:solidFill>
@@ -2844,49 +2550,49 @@
                 <a:ea typeface="맑은 고딕" pitchFamily="34" charset="-122"/>
                 <a:cs typeface="맑은 고딕" pitchFamily="34" charset="-120"/>
               </a:rPr>
-              <a:t>부서별 실습 워크샵</a:t>
-            </a:r>
-            <a:endParaRPr lang="en-US" sz="1300" dirty="0"/>
-          </a:p>
-          <a:p>
-            <a:pPr indent="0" marL="0">
-              <a:buNone/>
-            </a:pPr>
-            <a:r>
-              <a:rPr lang="en-US" sz="1100" dirty="0">
-                <a:solidFill>
-                  <a:srgbClr val="595959"/>
-                </a:solidFill>
-                <a:latin typeface="맑은 고딕" pitchFamily="34" charset="0"/>
-                <a:ea typeface="맑은 고딕" pitchFamily="34" charset="-122"/>
-                <a:cs typeface="맑은 고딕" pitchFamily="34" charset="-120"/>
-              </a:rPr>
-              <a:t>실제 업무 기반 Use case 도출 및 우선순위화(Canvas 활용)</a:t>
-            </a:r>
-            <a:endParaRPr lang="en-US" sz="1300" dirty="0"/>
-          </a:p>
-        </p:txBody>
-      </p:sp>
-      <p:sp>
-        <p:nvSpPr>
-          <p:cNvPr id="59" name="Shape 53"/>
+              <a:t>과제화 및</a:t>
+            </a:r>
+            <a:endParaRPr lang="en-US" sz="1200" dirty="0"/>
+          </a:p>
+          <a:p>
+            <a:pPr algn="ctr" indent="0" marL="0">
+              <a:buNone/>
+            </a:pPr>
+            <a:r>
+              <a:rPr lang="en-US" sz="1200" b="1" dirty="0">
+                <a:solidFill>
+                  <a:srgbClr val="262626"/>
+                </a:solidFill>
+                <a:latin typeface="맑은 고딕" pitchFamily="34" charset="0"/>
+                <a:ea typeface="맑은 고딕" pitchFamily="34" charset="-122"/>
+                <a:cs typeface="맑은 고딕" pitchFamily="34" charset="-120"/>
+              </a:rPr>
+              <a:t>우수사례 확산</a:t>
+            </a:r>
+            <a:endParaRPr lang="en-US" sz="1200" dirty="0"/>
+          </a:p>
+        </p:txBody>
+      </p:sp>
+      <p:sp>
+        <p:nvSpPr>
+          <p:cNvPr id="47" name="Shape 45"/>
           <p:cNvSpPr/>
           <p:nvPr/>
         </p:nvSpPr>
         <p:spPr>
           <a:xfrm>
-            <a:off x="6473952" y="5559552"/>
-            <a:ext cx="274320" cy="274320"/>
-          </a:xfrm>
-          <a:prstGeom prst="ellipse">
-            <a:avLst/>
-          </a:prstGeom>
-          <a:solidFill>
-            <a:srgbClr val="4A7BC8"/>
+            <a:off x="10076688" y="1828800"/>
+            <a:ext cx="246888" cy="246888"/>
+          </a:xfrm>
+          <a:prstGeom prst="rect">
+            <a:avLst/>
+          </a:prstGeom>
+          <a:solidFill>
+            <a:srgbClr val="7F7F7F"/>
           </a:solidFill>
           <a:ln w="12700">
             <a:solidFill>
-              <a:srgbClr val="4A7BC8"/>
+              <a:srgbClr val="7F7F7F"/>
             </a:solidFill>
             <a:prstDash val="solid"/>
           </a:ln>
@@ -2894,14 +2600,14 @@
       </p:sp>
       <p:sp>
         <p:nvSpPr>
-          <p:cNvPr id="60" name="Text 54"/>
+          <p:cNvPr id="48" name="Text 46"/>
           <p:cNvSpPr txBox="1"/>
           <p:nvPr/>
         </p:nvSpPr>
         <p:spPr>
           <a:xfrm>
-            <a:off x="6473952" y="5559552"/>
-            <a:ext cx="274320" cy="274320"/>
+            <a:off x="10076688" y="1828800"/>
+            <a:ext cx="246888" cy="246888"/>
           </a:xfrm>
           <a:prstGeom prst="rect">
             <a:avLst/>
@@ -2925,7 +2631,7 @@
                 <a:ea typeface="맑은 고딕" pitchFamily="34" charset="-122"/>
                 <a:cs typeface="맑은 고딕" pitchFamily="34" charset="-120"/>
               </a:rPr>
-              <a:t>4</a:t>
+              <a:t>3</a:t>
             </a:r>
             <a:endParaRPr lang="en-US" sz="1100" dirty="0"/>
           </a:p>
@@ -2933,80 +2639,24 @@
       </p:sp>
       <p:sp>
         <p:nvSpPr>
-          <p:cNvPr id="61" name="Text 55"/>
-          <p:cNvSpPr txBox="1"/>
-          <p:nvPr/>
-        </p:nvSpPr>
-        <p:spPr>
-          <a:xfrm>
-            <a:off x="6885432" y="5468112"/>
-            <a:ext cx="4846320" cy="475488"/>
-          </a:xfrm>
-          <a:prstGeom prst="rect">
-            <a:avLst/>
-          </a:prstGeom>
-          <a:noFill/>
-          <a:ln/>
-        </p:spPr>
-        <p:txBody>
-          <a:bodyPr wrap="square" lIns="0" tIns="0" rIns="0" bIns="0" rtlCol="0" anchor="ctr"/>
-          <a:lstStyle/>
-          <a:p>
-            <a:pPr indent="0" marL="0">
-              <a:buNone/>
-            </a:pPr>
-            <a:r>
-              <a:rPr lang="en-US" sz="1300" b="1" dirty="0">
-                <a:solidFill>
-                  <a:srgbClr val="262626"/>
-                </a:solidFill>
-                <a:latin typeface="맑은 고딕" pitchFamily="34" charset="0"/>
-                <a:ea typeface="맑은 고딕" pitchFamily="34" charset="-122"/>
-                <a:cs typeface="맑은 고딕" pitchFamily="34" charset="-120"/>
-              </a:rPr>
-              <a:t>발굴 결과 과제 연계</a:t>
-            </a:r>
-            <a:endParaRPr lang="en-US" sz="1300" dirty="0"/>
-          </a:p>
-          <a:p>
-            <a:pPr indent="0" marL="0">
-              <a:buNone/>
-            </a:pPr>
-            <a:r>
-              <a:rPr lang="en-US" sz="1100" dirty="0">
-                <a:solidFill>
-                  <a:srgbClr val="595959"/>
-                </a:solidFill>
-                <a:latin typeface="맑은 고딕" pitchFamily="34" charset="0"/>
-                <a:ea typeface="맑은 고딕" pitchFamily="34" charset="-122"/>
-                <a:cs typeface="맑은 고딕" pitchFamily="34" charset="-120"/>
-              </a:rPr>
-              <a:t>과제 후보 리스트로 Phase 1에 연계, 우수 사례 확산</a:t>
-            </a:r>
-            <a:endParaRPr lang="en-US" sz="1300" dirty="0"/>
-          </a:p>
-        </p:txBody>
-      </p:sp>
-      <p:sp>
-        <p:nvSpPr>
-          <p:cNvPr id="62" name="Shape 56"/>
+          <p:cNvPr id="49" name="Shape 47"/>
           <p:cNvSpPr/>
           <p:nvPr/>
         </p:nvSpPr>
         <p:spPr>
           <a:xfrm>
-            <a:off x="6336792" y="6080760"/>
-            <a:ext cx="5486400" cy="457200"/>
-          </a:xfrm>
-          <a:prstGeom prst="rect">
-            <a:avLst/>
-          </a:prstGeom>
-          <a:solidFill>
-            <a:srgbClr val="EAF0F8"/>
+            <a:off x="6537960" y="2880360"/>
+            <a:ext cx="246888" cy="246888"/>
+          </a:xfrm>
+          <a:prstGeom prst="rect">
+            <a:avLst/>
+          </a:prstGeom>
+          <a:solidFill>
+            <a:srgbClr val="7F7F7F"/>
           </a:solidFill>
           <a:ln w="12700">
             <a:solidFill>
-              <a:srgbClr val="EAF0F8"/>
+              <a:srgbClr val="7F7F7F"/>
             </a:solidFill>
             <a:prstDash val="solid"/>
           </a:ln>
@@ -3014,14 +2664,14 @@
       </p:sp>
       <p:sp>
         <p:nvSpPr>
-          <p:cNvPr id="63" name="Text 57"/>
+          <p:cNvPr id="50" name="Text 48"/>
           <p:cNvSpPr txBox="1"/>
           <p:nvPr/>
         </p:nvSpPr>
         <p:spPr>
           <a:xfrm>
-            <a:off x="6336792" y="6080760"/>
-            <a:ext cx="5486400" cy="457200"/>
+            <a:off x="6537960" y="2880360"/>
+            <a:ext cx="246888" cy="246888"/>
           </a:xfrm>
           <a:prstGeom prst="rect">
             <a:avLst/>
@@ -3037,21 +2687,49 @@
               <a:buNone/>
             </a:pPr>
             <a:r>
-              <a:rPr lang="en-US" sz="1300" b="1" dirty="0">
-                <a:solidFill>
-                  <a:srgbClr val="4A7BC8"/>
-                </a:solidFill>
-                <a:latin typeface="맑은 고딕" pitchFamily="34" charset="0"/>
-                <a:ea typeface="맑은 고딕" pitchFamily="34" charset="-122"/>
-                <a:cs typeface="맑은 고딕" pitchFamily="34" charset="-120"/>
-              </a:rPr>
-              <a:t>산출물  </a:t>
-            </a:r>
-            <a:pPr algn="ctr" indent="0" marL="0">
-              <a:buNone/>
-            </a:pPr>
-            <a:r>
-              <a:rPr lang="en-US" sz="1300" b="1" dirty="0">
+              <a:rPr lang="en-US" sz="1100" b="1" dirty="0">
+                <a:solidFill>
+                  <a:srgbClr val="FFFFFF"/>
+                </a:solidFill>
+                <a:latin typeface="맑은 고딕" pitchFamily="34" charset="0"/>
+                <a:ea typeface="맑은 고딕" pitchFamily="34" charset="-122"/>
+                <a:cs typeface="맑은 고딕" pitchFamily="34" charset="-120"/>
+              </a:rPr>
+              <a:t>1</a:t>
+            </a:r>
+            <a:endParaRPr lang="en-US" sz="1100" dirty="0"/>
+          </a:p>
+        </p:txBody>
+      </p:sp>
+      <p:sp>
+        <p:nvSpPr>
+          <p:cNvPr id="51" name="Text 49"/>
+          <p:cNvSpPr txBox="1"/>
+          <p:nvPr/>
+        </p:nvSpPr>
+        <p:spPr>
+          <a:xfrm>
+            <a:off x="6903720" y="2834640"/>
+            <a:ext cx="4846320" cy="338328"/>
+          </a:xfrm>
+          <a:prstGeom prst="rect">
+            <a:avLst/>
+          </a:prstGeom>
+          <a:noFill/>
+          <a:ln/>
+        </p:spPr>
+        <p:txBody>
+          <a:bodyPr wrap="square" lIns="0" tIns="0" rIns="0" bIns="0" rtlCol="0" anchor="ctr"/>
+          <a:lstStyle/>
+          <a:p>
+            <a:pPr indent="0" marL="0">
+              <a:spcAft>
+                <a:spcPts val="200"/>
+              </a:spcAft>
+              <a:buNone/>
+            </a:pPr>
+            <a:r>
+              <a:rPr lang="en-US" sz="1100" dirty="0">
                 <a:solidFill>
                   <a:srgbClr val="262626"/>
                 </a:solidFill>
@@ -3059,9 +2737,505 @@
                 <a:ea typeface="맑은 고딕" pitchFamily="34" charset="-122"/>
                 <a:cs typeface="맑은 고딕" pitchFamily="34" charset="-120"/>
               </a:rPr>
-              <a:t>Use case 발굴 Canvas, 교육 자료, 과제 후보 리스트</a:t>
-            </a:r>
-            <a:endParaRPr lang="en-US" sz="1300" dirty="0"/>
+              <a:t>Agent 개념·적용 사례 및 Agent 적용 가능 업무 유형 이해</a:t>
+            </a:r>
+            <a:endParaRPr lang="en-US" sz="1100" dirty="0"/>
+          </a:p>
+        </p:txBody>
+      </p:sp>
+      <p:sp>
+        <p:nvSpPr>
+          <p:cNvPr id="52" name="Shape 50"/>
+          <p:cNvSpPr/>
+          <p:nvPr/>
+        </p:nvSpPr>
+        <p:spPr>
+          <a:xfrm>
+            <a:off x="6537960" y="3246120"/>
+            <a:ext cx="246888" cy="246888"/>
+          </a:xfrm>
+          <a:prstGeom prst="rect">
+            <a:avLst/>
+          </a:prstGeom>
+          <a:solidFill>
+            <a:srgbClr val="7F7F7F"/>
+          </a:solidFill>
+          <a:ln w="12700">
+            <a:solidFill>
+              <a:srgbClr val="7F7F7F"/>
+            </a:solidFill>
+            <a:prstDash val="solid"/>
+          </a:ln>
+        </p:spPr>
+      </p:sp>
+      <p:sp>
+        <p:nvSpPr>
+          <p:cNvPr id="53" name="Text 51"/>
+          <p:cNvSpPr txBox="1"/>
+          <p:nvPr/>
+        </p:nvSpPr>
+        <p:spPr>
+          <a:xfrm>
+            <a:off x="6537960" y="3246120"/>
+            <a:ext cx="246888" cy="246888"/>
+          </a:xfrm>
+          <a:prstGeom prst="rect">
+            <a:avLst/>
+          </a:prstGeom>
+          <a:noFill/>
+          <a:ln/>
+        </p:spPr>
+        <p:txBody>
+          <a:bodyPr wrap="square" lIns="0" tIns="0" rIns="0" bIns="0" rtlCol="0" anchor="ctr"/>
+          <a:lstStyle/>
+          <a:p>
+            <a:pPr algn="ctr" indent="0" marL="0">
+              <a:buNone/>
+            </a:pPr>
+            <a:r>
+              <a:rPr lang="en-US" sz="1100" b="1" dirty="0">
+                <a:solidFill>
+                  <a:srgbClr val="FFFFFF"/>
+                </a:solidFill>
+                <a:latin typeface="맑은 고딕" pitchFamily="34" charset="0"/>
+                <a:ea typeface="맑은 고딕" pitchFamily="34" charset="-122"/>
+                <a:cs typeface="맑은 고딕" pitchFamily="34" charset="-120"/>
+              </a:rPr>
+              <a:t>2</a:t>
+            </a:r>
+            <a:endParaRPr lang="en-US" sz="1100" dirty="0"/>
+          </a:p>
+        </p:txBody>
+      </p:sp>
+      <p:sp>
+        <p:nvSpPr>
+          <p:cNvPr id="54" name="Text 52"/>
+          <p:cNvSpPr txBox="1"/>
+          <p:nvPr/>
+        </p:nvSpPr>
+        <p:spPr>
+          <a:xfrm>
+            <a:off x="6903720" y="3200400"/>
+            <a:ext cx="4846320" cy="338328"/>
+          </a:xfrm>
+          <a:prstGeom prst="rect">
+            <a:avLst/>
+          </a:prstGeom>
+          <a:noFill/>
+          <a:ln/>
+        </p:spPr>
+        <p:txBody>
+          <a:bodyPr wrap="square" lIns="0" tIns="0" rIns="0" bIns="0" rtlCol="0" anchor="ctr"/>
+          <a:lstStyle/>
+          <a:p>
+            <a:pPr indent="0" marL="0">
+              <a:spcAft>
+                <a:spcPts val="200"/>
+              </a:spcAft>
+              <a:buNone/>
+            </a:pPr>
+            <a:r>
+              <a:rPr lang="en-US" sz="1100" dirty="0">
+                <a:solidFill>
+                  <a:srgbClr val="262626"/>
+                </a:solidFill>
+                <a:latin typeface="맑은 고딕" pitchFamily="34" charset="0"/>
+                <a:ea typeface="맑은 고딕" pitchFamily="34" charset="-122"/>
+                <a:cs typeface="맑은 고딕" pitchFamily="34" charset="-120"/>
+              </a:rPr>
+              <a:t>Pain Point 도출 → 업무 분해 → Agent 적합성 판단으로 Use case 도출</a:t>
+            </a:r>
+            <a:endParaRPr lang="en-US" sz="1100" dirty="0"/>
+          </a:p>
+        </p:txBody>
+      </p:sp>
+      <p:sp>
+        <p:nvSpPr>
+          <p:cNvPr id="55" name="Shape 53"/>
+          <p:cNvSpPr/>
+          <p:nvPr/>
+        </p:nvSpPr>
+        <p:spPr>
+          <a:xfrm>
+            <a:off x="6537960" y="3611880"/>
+            <a:ext cx="246888" cy="246888"/>
+          </a:xfrm>
+          <a:prstGeom prst="rect">
+            <a:avLst/>
+          </a:prstGeom>
+          <a:solidFill>
+            <a:srgbClr val="7F7F7F"/>
+          </a:solidFill>
+          <a:ln w="12700">
+            <a:solidFill>
+              <a:srgbClr val="7F7F7F"/>
+            </a:solidFill>
+            <a:prstDash val="solid"/>
+          </a:ln>
+        </p:spPr>
+      </p:sp>
+      <p:sp>
+        <p:nvSpPr>
+          <p:cNvPr id="56" name="Text 54"/>
+          <p:cNvSpPr txBox="1"/>
+          <p:nvPr/>
+        </p:nvSpPr>
+        <p:spPr>
+          <a:xfrm>
+            <a:off x="6537960" y="3611880"/>
+            <a:ext cx="246888" cy="246888"/>
+          </a:xfrm>
+          <a:prstGeom prst="rect">
+            <a:avLst/>
+          </a:prstGeom>
+          <a:noFill/>
+          <a:ln/>
+        </p:spPr>
+        <p:txBody>
+          <a:bodyPr wrap="square" lIns="0" tIns="0" rIns="0" bIns="0" rtlCol="0" anchor="ctr"/>
+          <a:lstStyle/>
+          <a:p>
+            <a:pPr algn="ctr" indent="0" marL="0">
+              <a:buNone/>
+            </a:pPr>
+            <a:r>
+              <a:rPr lang="en-US" sz="1100" b="1" dirty="0">
+                <a:solidFill>
+                  <a:srgbClr val="FFFFFF"/>
+                </a:solidFill>
+                <a:latin typeface="맑은 고딕" pitchFamily="34" charset="0"/>
+                <a:ea typeface="맑은 고딕" pitchFamily="34" charset="-122"/>
+                <a:cs typeface="맑은 고딕" pitchFamily="34" charset="-120"/>
+              </a:rPr>
+              <a:t>3</a:t>
+            </a:r>
+            <a:endParaRPr lang="en-US" sz="1100" dirty="0"/>
+          </a:p>
+        </p:txBody>
+      </p:sp>
+      <p:sp>
+        <p:nvSpPr>
+          <p:cNvPr id="57" name="Text 55"/>
+          <p:cNvSpPr txBox="1"/>
+          <p:nvPr/>
+        </p:nvSpPr>
+        <p:spPr>
+          <a:xfrm>
+            <a:off x="6903720" y="3566160"/>
+            <a:ext cx="4846320" cy="548640"/>
+          </a:xfrm>
+          <a:prstGeom prst="rect">
+            <a:avLst/>
+          </a:prstGeom>
+          <a:noFill/>
+          <a:ln/>
+        </p:spPr>
+        <p:txBody>
+          <a:bodyPr wrap="square" lIns="0" tIns="0" rIns="0" bIns="0" rtlCol="0" anchor="t"/>
+          <a:lstStyle/>
+          <a:p>
+            <a:pPr indent="0" marL="0">
+              <a:spcAft>
+                <a:spcPts val="200"/>
+              </a:spcAft>
+              <a:buNone/>
+            </a:pPr>
+            <a:r>
+              <a:rPr lang="en-US" sz="1100" dirty="0">
+                <a:solidFill>
+                  <a:srgbClr val="262626"/>
+                </a:solidFill>
+                <a:latin typeface="맑은 고딕" pitchFamily="34" charset="0"/>
+                <a:ea typeface="맑은 고딕" pitchFamily="34" charset="-122"/>
+                <a:cs typeface="맑은 고딕" pitchFamily="34" charset="-120"/>
+              </a:rPr>
+              <a:t>실무자 주도 Use case 우선순위화 + 과제 후보 리스트 등록</a:t>
+            </a:r>
+            <a:endParaRPr lang="en-US" sz="1100" dirty="0"/>
+          </a:p>
+          <a:p>
+            <a:pPr indent="0" marL="0">
+              <a:spcAft>
+                <a:spcPts val="200"/>
+              </a:spcAft>
+              <a:buNone/>
+            </a:pPr>
+            <a:r>
+              <a:rPr lang="en-US" sz="1100" dirty="0">
+                <a:solidFill>
+                  <a:srgbClr val="1F3FBF"/>
+                </a:solidFill>
+                <a:latin typeface="맑은 고딕" pitchFamily="34" charset="0"/>
+                <a:ea typeface="맑은 고딕" pitchFamily="34" charset="-122"/>
+                <a:cs typeface="맑은 고딕" pitchFamily="34" charset="-120"/>
+              </a:rPr>
+              <a:t>→ Phase 1 과제 발굴과 연계, 타 부서·계열사 전파</a:t>
+            </a:r>
+            <a:endParaRPr lang="en-US" sz="1100" dirty="0"/>
+          </a:p>
+        </p:txBody>
+      </p:sp>
+      <p:sp>
+        <p:nvSpPr>
+          <p:cNvPr id="58" name="Shape 56"/>
+          <p:cNvSpPr/>
+          <p:nvPr/>
+        </p:nvSpPr>
+        <p:spPr>
+          <a:xfrm>
+            <a:off x="6446520" y="4251960"/>
+            <a:ext cx="5212080" cy="475488"/>
+          </a:xfrm>
+          <a:prstGeom prst="roundRect">
+            <a:avLst>
+              <a:gd name="adj" fmla="val 15385"/>
+            </a:avLst>
+          </a:prstGeom>
+          <a:solidFill>
+            <a:srgbClr val="F2F2F2"/>
+          </a:solidFill>
+          <a:ln w="12700">
+            <a:solidFill>
+              <a:srgbClr val="F2F2F2"/>
+            </a:solidFill>
+            <a:prstDash val="solid"/>
+          </a:ln>
+        </p:spPr>
+      </p:sp>
+      <p:sp>
+        <p:nvSpPr>
+          <p:cNvPr id="59" name="Text 57"/>
+          <p:cNvSpPr txBox="1"/>
+          <p:nvPr/>
+        </p:nvSpPr>
+        <p:spPr>
+          <a:xfrm>
+            <a:off x="6446520" y="4251960"/>
+            <a:ext cx="5212080" cy="475488"/>
+          </a:xfrm>
+          <a:prstGeom prst="rect">
+            <a:avLst/>
+          </a:prstGeom>
+          <a:noFill/>
+          <a:ln/>
+        </p:spPr>
+        <p:txBody>
+          <a:bodyPr wrap="square" lIns="0" tIns="0" rIns="0" bIns="0" rtlCol="0" anchor="ctr"/>
+          <a:lstStyle/>
+          <a:p>
+            <a:pPr algn="ctr" indent="0" marL="0">
+              <a:buNone/>
+            </a:pPr>
+            <a:r>
+              <a:rPr lang="en-US" sz="1350" b="1" dirty="0">
+                <a:solidFill>
+                  <a:srgbClr val="262626"/>
+                </a:solidFill>
+                <a:latin typeface="맑은 고딕" pitchFamily="34" charset="0"/>
+                <a:ea typeface="맑은 고딕" pitchFamily="34" charset="-122"/>
+                <a:cs typeface="맑은 고딕" pitchFamily="34" charset="-120"/>
+              </a:rPr>
+              <a:t>현업의 실제 업무와 Pain Point 중심의 Use case 발굴</a:t>
+            </a:r>
+            <a:endParaRPr lang="en-US" sz="1350" dirty="0"/>
+          </a:p>
+        </p:txBody>
+      </p:sp>
+      <p:sp>
+        <p:nvSpPr>
+          <p:cNvPr id="60" name="Shape 58"/>
+          <p:cNvSpPr/>
+          <p:nvPr/>
+        </p:nvSpPr>
+        <p:spPr>
+          <a:xfrm>
+            <a:off x="6446520" y="4818888"/>
+            <a:ext cx="5212080" cy="475488"/>
+          </a:xfrm>
+          <a:prstGeom prst="roundRect">
+            <a:avLst>
+              <a:gd name="adj" fmla="val 15385"/>
+            </a:avLst>
+          </a:prstGeom>
+          <a:solidFill>
+            <a:srgbClr val="F2F2F2"/>
+          </a:solidFill>
+          <a:ln w="12700">
+            <a:solidFill>
+              <a:srgbClr val="F2F2F2"/>
+            </a:solidFill>
+            <a:prstDash val="solid"/>
+          </a:ln>
+        </p:spPr>
+      </p:sp>
+      <p:sp>
+        <p:nvSpPr>
+          <p:cNvPr id="61" name="Text 59"/>
+          <p:cNvSpPr txBox="1"/>
+          <p:nvPr/>
+        </p:nvSpPr>
+        <p:spPr>
+          <a:xfrm>
+            <a:off x="6446520" y="4818888"/>
+            <a:ext cx="5212080" cy="475488"/>
+          </a:xfrm>
+          <a:prstGeom prst="rect">
+            <a:avLst/>
+          </a:prstGeom>
+          <a:noFill/>
+          <a:ln/>
+        </p:spPr>
+        <p:txBody>
+          <a:bodyPr wrap="square" lIns="0" tIns="0" rIns="0" bIns="0" rtlCol="0" anchor="ctr"/>
+          <a:lstStyle/>
+          <a:p>
+            <a:pPr algn="ctr" indent="0" marL="0">
+              <a:buNone/>
+            </a:pPr>
+            <a:r>
+              <a:rPr lang="en-US" sz="1350" b="1" dirty="0">
+                <a:solidFill>
+                  <a:srgbClr val="262626"/>
+                </a:solidFill>
+                <a:latin typeface="맑은 고딕" pitchFamily="34" charset="0"/>
+                <a:ea typeface="맑은 고딕" pitchFamily="34" charset="-122"/>
+                <a:cs typeface="맑은 고딕" pitchFamily="34" charset="-120"/>
+              </a:rPr>
+              <a:t>업무 영역별 Agent 적용 사례 및 발굴 Canvas 제공</a:t>
+            </a:r>
+            <a:endParaRPr lang="en-US" sz="1350" dirty="0"/>
+          </a:p>
+        </p:txBody>
+      </p:sp>
+      <p:sp>
+        <p:nvSpPr>
+          <p:cNvPr id="62" name="Shape 60"/>
+          <p:cNvSpPr/>
+          <p:nvPr/>
+        </p:nvSpPr>
+        <p:spPr>
+          <a:xfrm>
+            <a:off x="6446520" y="5385816"/>
+            <a:ext cx="5212080" cy="475488"/>
+          </a:xfrm>
+          <a:prstGeom prst="roundRect">
+            <a:avLst>
+              <a:gd name="adj" fmla="val 15385"/>
+            </a:avLst>
+          </a:prstGeom>
+          <a:solidFill>
+            <a:srgbClr val="F2F2F2"/>
+          </a:solidFill>
+          <a:ln w="12700">
+            <a:solidFill>
+              <a:srgbClr val="F2F2F2"/>
+            </a:solidFill>
+            <a:prstDash val="solid"/>
+          </a:ln>
+        </p:spPr>
+      </p:sp>
+      <p:sp>
+        <p:nvSpPr>
+          <p:cNvPr id="63" name="Text 61"/>
+          <p:cNvSpPr txBox="1"/>
+          <p:nvPr/>
+        </p:nvSpPr>
+        <p:spPr>
+          <a:xfrm>
+            <a:off x="6446520" y="5385816"/>
+            <a:ext cx="5212080" cy="475488"/>
+          </a:xfrm>
+          <a:prstGeom prst="rect">
+            <a:avLst/>
+          </a:prstGeom>
+          <a:noFill/>
+          <a:ln/>
+        </p:spPr>
+        <p:txBody>
+          <a:bodyPr wrap="square" lIns="0" tIns="0" rIns="0" bIns="0" rtlCol="0" anchor="ctr"/>
+          <a:lstStyle/>
+          <a:p>
+            <a:pPr algn="ctr" indent="0" marL="0">
+              <a:buNone/>
+            </a:pPr>
+            <a:r>
+              <a:rPr lang="en-US" sz="1350" b="1" dirty="0">
+                <a:solidFill>
+                  <a:srgbClr val="262626"/>
+                </a:solidFill>
+                <a:latin typeface="맑은 고딕" pitchFamily="34" charset="0"/>
+                <a:ea typeface="맑은 고딕" pitchFamily="34" charset="-122"/>
+                <a:cs typeface="맑은 고딕" pitchFamily="34" charset="-120"/>
+              </a:rPr>
+              <a:t>참가자 주도 실습을 통한 실행 가능한 과제 후보 도출</a:t>
+            </a:r>
+            <a:endParaRPr lang="en-US" sz="1350" dirty="0"/>
+          </a:p>
+        </p:txBody>
+      </p:sp>
+      <p:sp>
+        <p:nvSpPr>
+          <p:cNvPr id="64" name="Shape 62"/>
+          <p:cNvSpPr/>
+          <p:nvPr/>
+        </p:nvSpPr>
+        <p:spPr>
+          <a:xfrm>
+            <a:off x="6446520" y="5952744"/>
+            <a:ext cx="5212080" cy="475488"/>
+          </a:xfrm>
+          <a:prstGeom prst="roundRect">
+            <a:avLst>
+              <a:gd name="adj" fmla="val 15385"/>
+            </a:avLst>
+          </a:prstGeom>
+          <a:solidFill>
+            <a:srgbClr val="F2F2F2"/>
+          </a:solidFill>
+          <a:ln w="12700">
+            <a:solidFill>
+              <a:srgbClr val="F2F2F2"/>
+            </a:solidFill>
+            <a:prstDash val="solid"/>
+          </a:ln>
+        </p:spPr>
+      </p:sp>
+      <p:sp>
+        <p:nvSpPr>
+          <p:cNvPr id="65" name="Text 63"/>
+          <p:cNvSpPr txBox="1"/>
+          <p:nvPr/>
+        </p:nvSpPr>
+        <p:spPr>
+          <a:xfrm>
+            <a:off x="6446520" y="5952744"/>
+            <a:ext cx="5212080" cy="475488"/>
+          </a:xfrm>
+          <a:prstGeom prst="rect">
+            <a:avLst/>
+          </a:prstGeom>
+          <a:noFill/>
+          <a:ln/>
+        </p:spPr>
+        <p:txBody>
+          <a:bodyPr wrap="square" lIns="0" tIns="0" rIns="0" bIns="0" rtlCol="0" anchor="ctr"/>
+          <a:lstStyle/>
+          <a:p>
+            <a:pPr algn="ctr" indent="0" marL="0">
+              <a:buNone/>
+            </a:pPr>
+            <a:r>
+              <a:rPr lang="en-US" sz="1350" b="1" dirty="0">
+                <a:solidFill>
+                  <a:srgbClr val="262626"/>
+                </a:solidFill>
+                <a:latin typeface="맑은 고딕" pitchFamily="34" charset="0"/>
+                <a:ea typeface="맑은 고딕" pitchFamily="34" charset="-122"/>
+                <a:cs typeface="맑은 고딕" pitchFamily="34" charset="-120"/>
+              </a:rPr>
+              <a:t>AX컨설턴트·AI 전문가의 현장 코칭 및 기술 적합성 검토</a:t>
+            </a:r>
+            <a:endParaRPr lang="en-US" sz="1350" dirty="0"/>
           </a:p>
         </p:txBody>
       </p:sp>

</xml_diff>